<commit_message>
feat: tambah logo Kota Bekasi di presentasi Perda No.14/2018
</commit_message>
<xml_diff>
--- a/Ringkasan_Perda_Bekasi_No_14_2018.pptx
+++ b/Ringkasan_Perda_Bekasi_No_14_2018.pptx
@@ -3186,16 +3186,40 @@
           </a:p>
         </p:txBody>
       </p:sp>
-      <p:sp>
-        <p:nvSpPr>
-          <p:cNvPr id="4" name="TextBox 3"/>
+      <p:pic>
+        <p:nvPicPr>
+          <p:cNvPr id="4" name="Picture 3" descr="logo_bekasi.png"/>
+          <p:cNvPicPr>
+            <a:picLocks noChangeAspect="1"/>
+          </p:cNvPicPr>
+          <p:nvPr/>
+        </p:nvPicPr>
+        <p:blipFill>
+          <a:blip r:embed="rId2"/>
+          <a:stretch>
+            <a:fillRect/>
+          </a:stretch>
+        </p:blipFill>
+        <p:spPr>
+          <a:xfrm>
+            <a:off x="5303520" y="548640"/>
+            <a:ext cx="1254264" cy="1463040"/>
+          </a:xfrm>
+          <a:prstGeom prst="rect">
+            <a:avLst/>
+          </a:prstGeom>
+        </p:spPr>
+      </p:pic>
+      <p:sp>
+        <p:nvSpPr>
+          <p:cNvPr id="5" name="TextBox 4"/>
           <p:cNvSpPr txBox="1"/>
           <p:nvPr/>
         </p:nvSpPr>
         <p:spPr>
           <a:xfrm>
-            <a:off x="914400" y="1097280"/>
-            <a:ext cx="10058400" cy="1097280"/>
+            <a:off x="914400" y="914400"/>
+            <a:ext cx="10058400" cy="548640"/>
           </a:xfrm>
           <a:prstGeom prst="rect">
             <a:avLst/>
@@ -3209,7 +3233,7 @@
           <a:lstStyle/>
           <a:p>
             <a:pPr algn="ctr">
-              <a:defRPr sz="2200" b="0">
+              <a:defRPr sz="2000" b="0">
                 <a:solidFill>
                   <a:srgbClr val="AACCEE"/>
                 </a:solidFill>
@@ -3224,14 +3248,14 @@
       </p:sp>
       <p:sp>
         <p:nvSpPr>
-          <p:cNvPr id="5" name="TextBox 4"/>
+          <p:cNvPr id="6" name="TextBox 5"/>
           <p:cNvSpPr txBox="1"/>
           <p:nvPr/>
         </p:nvSpPr>
         <p:spPr>
           <a:xfrm>
             <a:off x="914400" y="2743200"/>
-            <a:ext cx="10058400" cy="1371600"/>
+            <a:ext cx="10058400" cy="1280160"/>
           </a:xfrm>
           <a:prstGeom prst="rect">
             <a:avLst/>
@@ -3245,7 +3269,7 @@
           <a:lstStyle/>
           <a:p>
             <a:pPr algn="ctr">
-              <a:defRPr sz="4400" b="1">
+              <a:defRPr sz="4200" b="1">
                 <a:solidFill>
                   <a:srgbClr val="FFFFFF"/>
                 </a:solidFill>
@@ -3264,7 +3288,7 @@
       </p:sp>
       <p:sp>
         <p:nvSpPr>
-          <p:cNvPr id="6" name="TextBox 5"/>
+          <p:cNvPr id="7" name="TextBox 6"/>
           <p:cNvSpPr txBox="1"/>
           <p:nvPr/>
         </p:nvSpPr>
@@ -3304,13 +3328,13 @@
       </p:sp>
       <p:sp>
         <p:nvSpPr>
-          <p:cNvPr id="7" name="TextBox 6"/>
+          <p:cNvPr id="8" name="TextBox 7"/>
           <p:cNvSpPr txBox="1"/>
           <p:nvPr/>
         </p:nvSpPr>
         <p:spPr>
           <a:xfrm>
-            <a:off x="914400" y="5669280"/>
+            <a:off x="914400" y="5760720"/>
             <a:ext cx="10058400" cy="457200"/>
           </a:xfrm>
           <a:prstGeom prst="rect">
@@ -3325,7 +3349,7 @@
           <a:lstStyle/>
           <a:p>
             <a:pPr algn="ctr">
-              <a:defRPr sz="1400" b="0">
+              <a:defRPr sz="1300" b="0">
                 <a:solidFill>
                   <a:srgbClr val="88AACC"/>
                 </a:solidFill>
@@ -3407,16 +3431,40 @@
           </a:p>
         </p:txBody>
       </p:sp>
-      <p:sp>
-        <p:nvSpPr>
-          <p:cNvPr id="3" name="TextBox 2"/>
+      <p:pic>
+        <p:nvPicPr>
+          <p:cNvPr id="3" name="Picture 2" descr="logo_bekasi.png"/>
+          <p:cNvPicPr>
+            <a:picLocks noChangeAspect="1"/>
+          </p:cNvPicPr>
+          <p:nvPr/>
+        </p:nvPicPr>
+        <p:blipFill>
+          <a:blip r:embed="rId2"/>
+          <a:stretch>
+            <a:fillRect/>
+          </a:stretch>
+        </p:blipFill>
+        <p:spPr>
+          <a:xfrm>
+            <a:off x="274320" y="91440"/>
+            <a:ext cx="548740" cy="640080"/>
+          </a:xfrm>
+          <a:prstGeom prst="rect">
+            <a:avLst/>
+          </a:prstGeom>
+        </p:spPr>
+      </p:pic>
+      <p:sp>
+        <p:nvSpPr>
+          <p:cNvPr id="4" name="TextBox 3"/>
           <p:cNvSpPr txBox="1"/>
           <p:nvPr/>
         </p:nvSpPr>
         <p:spPr>
           <a:xfrm>
-            <a:off x="457200" y="137160"/>
-            <a:ext cx="10972800" cy="640080"/>
+            <a:off x="1188720" y="137160"/>
+            <a:ext cx="10058400" cy="640080"/>
           </a:xfrm>
           <a:prstGeom prst="rect">
             <a:avLst/>
@@ -3445,7 +3493,7 @@
       </p:sp>
       <p:sp>
         <p:nvSpPr>
-          <p:cNvPr id="4" name="Rectangle 3"/>
+          <p:cNvPr id="5" name="Rectangle 4"/>
           <p:cNvSpPr/>
           <p:nvPr/>
         </p:nvSpPr>
@@ -3488,7 +3536,7 @@
       </p:sp>
       <p:sp>
         <p:nvSpPr>
-          <p:cNvPr id="5" name="TextBox 4"/>
+          <p:cNvPr id="6" name="TextBox 5"/>
           <p:cNvSpPr txBox="1"/>
           <p:nvPr/>
         </p:nvSpPr>
@@ -3517,14 +3565,14 @@
               </a:defRPr>
             </a:pPr>
             <a:r>
-              <a:t>LATAR BELAKANG</a:t>
-            </a:r>
-          </a:p>
-        </p:txBody>
-      </p:sp>
-      <p:sp>
-        <p:nvSpPr>
-          <p:cNvPr id="6" name="TextBox 5"/>
+              <a:t>▸  LATAR BELAKANG</a:t>
+            </a:r>
+          </a:p>
+        </p:txBody>
+      </p:sp>
+      <p:sp>
+        <p:nvSpPr>
+          <p:cNvPr id="7" name="TextBox 6"/>
           <p:cNvSpPr txBox="1"/>
           <p:nvPr/>
         </p:nvSpPr>
@@ -3546,7 +3594,7 @@
           <a:p>
             <a:pPr>
               <a:spcAft>
-                <a:spcPts val="600"/>
+                <a:spcPts val="400"/>
               </a:spcAft>
               <a:defRPr sz="1600">
                 <a:solidFill>
@@ -3556,13 +3604,13 @@
               </a:defRPr>
             </a:pPr>
             <a:r>
-              <a:t>▸ Mengoptimalkan &amp; meningkatkan Pendapatan Asli Daerah (PAD) dari Pajak Restoran</a:t>
+              <a:t>Mengoptimalkan &amp; meningkatkan Pendapatan</a:t>
             </a:r>
           </a:p>
           <a:p>
             <a:pPr>
               <a:spcAft>
-                <a:spcPts val="600"/>
+                <a:spcPts val="400"/>
               </a:spcAft>
               <a:defRPr sz="1600">
                 <a:solidFill>
@@ -3571,11 +3619,14 @@
                 <a:latin typeface="Calibri"/>
               </a:defRPr>
             </a:pPr>
+            <a:r>
+              <a:t>Asli Daerah (PAD) dari Pajak Restoran</a:t>
+            </a:r>
           </a:p>
           <a:p>
             <a:pPr>
               <a:spcAft>
-                <a:spcPts val="600"/>
+                <a:spcPts val="400"/>
               </a:spcAft>
               <a:defRPr sz="1600">
                 <a:solidFill>
@@ -3584,15 +3635,44 @@
                 <a:latin typeface="Calibri"/>
               </a:defRPr>
             </a:pPr>
-            <a:r>
-              <a:t>▸ Menyesuaikan Perda No. 08/2011 dengan kondisi terkini</a:t>
-            </a:r>
-          </a:p>
-        </p:txBody>
-      </p:sp>
-      <p:sp>
-        <p:nvSpPr>
-          <p:cNvPr id="7" name="Rectangle 6"/>
+          </a:p>
+          <a:p>
+            <a:pPr>
+              <a:spcAft>
+                <a:spcPts val="400"/>
+              </a:spcAft>
+              <a:defRPr sz="1600">
+                <a:solidFill>
+                  <a:srgbClr val="2D2D2D"/>
+                </a:solidFill>
+                <a:latin typeface="Calibri"/>
+              </a:defRPr>
+            </a:pPr>
+            <a:r>
+              <a:t>Menyesuaikan Perda No. 08/2011 dengan</a:t>
+            </a:r>
+          </a:p>
+          <a:p>
+            <a:pPr>
+              <a:spcAft>
+                <a:spcPts val="400"/>
+              </a:spcAft>
+              <a:defRPr sz="1600">
+                <a:solidFill>
+                  <a:srgbClr val="2D2D2D"/>
+                </a:solidFill>
+                <a:latin typeface="Calibri"/>
+              </a:defRPr>
+            </a:pPr>
+            <a:r>
+              <a:t>kondisi terkini</a:t>
+            </a:r>
+          </a:p>
+        </p:txBody>
+      </p:sp>
+      <p:sp>
+        <p:nvSpPr>
+          <p:cNvPr id="8" name="Rectangle 7"/>
           <p:cNvSpPr/>
           <p:nvPr/>
         </p:nvSpPr>
@@ -3635,7 +3715,7 @@
       </p:sp>
       <p:sp>
         <p:nvSpPr>
-          <p:cNvPr id="8" name="TextBox 7"/>
+          <p:cNvPr id="9" name="TextBox 8"/>
           <p:cNvSpPr txBox="1"/>
           <p:nvPr/>
         </p:nvSpPr>
@@ -3664,14 +3744,14 @@
               </a:defRPr>
             </a:pPr>
             <a:r>
-              <a:t>DASAR HUKUM UTAMA</a:t>
-            </a:r>
-          </a:p>
-        </p:txBody>
-      </p:sp>
-      <p:sp>
-        <p:nvSpPr>
-          <p:cNvPr id="9" name="TextBox 8"/>
+              <a:t>▸  DASAR HUKUM UTAMA</a:t>
+            </a:r>
+          </a:p>
+        </p:txBody>
+      </p:sp>
+      <p:sp>
+        <p:nvSpPr>
+          <p:cNvPr id="10" name="TextBox 9"/>
           <p:cNvSpPr txBox="1"/>
           <p:nvPr/>
         </p:nvSpPr>
@@ -3693,7 +3773,7 @@
           <a:p>
             <a:pPr>
               <a:spcAft>
-                <a:spcPts val="600"/>
+                <a:spcPts val="300"/>
               </a:spcAft>
               <a:defRPr sz="1400">
                 <a:solidFill>
@@ -3703,13 +3783,13 @@
               </a:defRPr>
             </a:pPr>
             <a:r>
-              <a:t>▸ UU No. 28/2009 — Pajak Daerah &amp; Retribusi Daerah</a:t>
+              <a:t>UU No. 28/2009 — Pajak Daerah &amp; Retribusi</a:t>
             </a:r>
           </a:p>
           <a:p>
             <a:pPr>
               <a:spcAft>
-                <a:spcPts val="600"/>
+                <a:spcPts val="300"/>
               </a:spcAft>
               <a:defRPr sz="1400">
                 <a:solidFill>
@@ -3719,13 +3799,13 @@
               </a:defRPr>
             </a:pPr>
             <a:r>
-              <a:t>▸ UU No. 23/2014 — Pemerintahan Daerah</a:t>
+              <a:t>UU No. 23/2014 — Pemerintahan Daerah</a:t>
             </a:r>
           </a:p>
           <a:p>
             <a:pPr>
               <a:spcAft>
-                <a:spcPts val="600"/>
+                <a:spcPts val="300"/>
               </a:spcAft>
               <a:defRPr sz="1400">
                 <a:solidFill>
@@ -3735,13 +3815,13 @@
               </a:defRPr>
             </a:pPr>
             <a:r>
-              <a:t>▸ UU No. 6/1983 — Ketentuan Umum Perpajakan (diubah dgn UU 16/2009)</a:t>
+              <a:t>UU No. 6/1983 jo. UU 16/2009 — Ketentuan Perpajakan</a:t>
             </a:r>
           </a:p>
           <a:p>
             <a:pPr>
               <a:spcAft>
-                <a:spcPts val="600"/>
+                <a:spcPts val="300"/>
               </a:spcAft>
               <a:defRPr sz="1400">
                 <a:solidFill>
@@ -3751,13 +3831,13 @@
               </a:defRPr>
             </a:pPr>
             <a:r>
-              <a:t>▸ PP No. 55/2016 — Ketentuan &amp; Tata Cara Pemungutan Pajak Daerah</a:t>
+              <a:t>PP No. 55/2016 — Pemungutan Pajak Daerah</a:t>
             </a:r>
           </a:p>
           <a:p>
             <a:pPr>
               <a:spcAft>
-                <a:spcPts val="600"/>
+                <a:spcPts val="300"/>
               </a:spcAft>
               <a:defRPr sz="1400">
                 <a:solidFill>
@@ -3767,13 +3847,13 @@
               </a:defRPr>
             </a:pPr>
             <a:r>
-              <a:t>▸ PP No. 69/2010 — Insentif Pemungutan Pajak Daerah</a:t>
+              <a:t>PP No. 69/2010 — Insentif Pajak Daerah</a:t>
             </a:r>
           </a:p>
           <a:p>
             <a:pPr>
               <a:spcAft>
-                <a:spcPts val="600"/>
+                <a:spcPts val="300"/>
               </a:spcAft>
               <a:defRPr sz="1400">
                 <a:solidFill>
@@ -3783,14 +3863,14 @@
               </a:defRPr>
             </a:pPr>
             <a:r>
-              <a:t>▸ Perda Kota Bekasi No. 08/2011 — Pajak Restoran</a:t>
-            </a:r>
-          </a:p>
-        </p:txBody>
-      </p:sp>
-      <p:sp>
-        <p:nvSpPr>
-          <p:cNvPr id="10" name="Rectangle 9"/>
+              <a:t>Perda Kota Bekasi No. 08/2011 — Pajak Restoran</a:t>
+            </a:r>
+          </a:p>
+        </p:txBody>
+      </p:sp>
+      <p:sp>
+        <p:nvSpPr>
+          <p:cNvPr id="11" name="Rectangle 10"/>
           <p:cNvSpPr/>
           <p:nvPr/>
         </p:nvSpPr>
@@ -3833,7 +3913,7 @@
       </p:sp>
       <p:sp>
         <p:nvSpPr>
-          <p:cNvPr id="11" name="TextBox 10"/>
+          <p:cNvPr id="12" name="TextBox 11"/>
           <p:cNvSpPr txBox="1"/>
           <p:nvPr/>
         </p:nvSpPr>
@@ -3936,16 +4016,40 @@
           </a:p>
         </p:txBody>
       </p:sp>
-      <p:sp>
-        <p:nvSpPr>
-          <p:cNvPr id="3" name="TextBox 2"/>
+      <p:pic>
+        <p:nvPicPr>
+          <p:cNvPr id="3" name="Picture 2" descr="logo_bekasi.png"/>
+          <p:cNvPicPr>
+            <a:picLocks noChangeAspect="1"/>
+          </p:cNvPicPr>
+          <p:nvPr/>
+        </p:nvPicPr>
+        <p:blipFill>
+          <a:blip r:embed="rId2"/>
+          <a:stretch>
+            <a:fillRect/>
+          </a:stretch>
+        </p:blipFill>
+        <p:spPr>
+          <a:xfrm>
+            <a:off x="274320" y="91440"/>
+            <a:ext cx="548740" cy="640080"/>
+          </a:xfrm>
+          <a:prstGeom prst="rect">
+            <a:avLst/>
+          </a:prstGeom>
+        </p:spPr>
+      </p:pic>
+      <p:sp>
+        <p:nvSpPr>
+          <p:cNvPr id="4" name="TextBox 3"/>
           <p:cNvSpPr txBox="1"/>
           <p:nvPr/>
         </p:nvSpPr>
         <p:spPr>
           <a:xfrm>
-            <a:off x="457200" y="137160"/>
-            <a:ext cx="10972800" cy="640080"/>
+            <a:off x="1188720" y="137160"/>
+            <a:ext cx="10058400" cy="640080"/>
           </a:xfrm>
           <a:prstGeom prst="rect">
             <a:avLst/>
@@ -3967,14 +4071,14 @@
               </a:defRPr>
             </a:pPr>
             <a:r>
-              <a:t>PASAL I — PERUBAHAN UTAMA: OBJEK PAJAK RESTORAN</a:t>
-            </a:r>
-          </a:p>
-        </p:txBody>
-      </p:sp>
-      <p:sp>
-        <p:nvSpPr>
-          <p:cNvPr id="4" name="Rectangle 3"/>
+              <a:t>PASAL I — PERUBAHAN UTAMA: OBJEK PAJAK</a:t>
+            </a:r>
+          </a:p>
+        </p:txBody>
+      </p:sp>
+      <p:sp>
+        <p:nvSpPr>
+          <p:cNvPr id="5" name="Rectangle 4"/>
           <p:cNvSpPr/>
           <p:nvPr/>
         </p:nvSpPr>
@@ -4017,7 +4121,7 @@
       </p:sp>
       <p:sp>
         <p:nvSpPr>
-          <p:cNvPr id="5" name="TextBox 4"/>
+          <p:cNvPr id="6" name="TextBox 5"/>
           <p:cNvSpPr txBox="1"/>
           <p:nvPr/>
         </p:nvSpPr>
@@ -4046,14 +4150,14 @@
               </a:defRPr>
             </a:pPr>
             <a:r>
-              <a:t>Ayat (1)  —  Objek Pajak Restoran (diperluas)</a:t>
-            </a:r>
-          </a:p>
-        </p:txBody>
-      </p:sp>
-      <p:sp>
-        <p:nvSpPr>
-          <p:cNvPr id="6" name="TextBox 5"/>
+              <a:t>Ayat (1) — Objek Pajak Restoran (diperluas)</a:t>
+            </a:r>
+          </a:p>
+        </p:txBody>
+      </p:sp>
+      <p:sp>
+        <p:nvSpPr>
+          <p:cNvPr id="7" name="TextBox 6"/>
           <p:cNvSpPr txBox="1"/>
           <p:nvPr/>
         </p:nvSpPr>
@@ -4075,7 +4179,7 @@
           <a:p>
             <a:pPr>
               <a:spcAft>
-                <a:spcPts val="600"/>
+                <a:spcPts val="300"/>
               </a:spcAft>
               <a:defRPr sz="1600">
                 <a:solidFill>
@@ -4085,13 +4189,13 @@
               </a:defRPr>
             </a:pPr>
             <a:r>
-              <a:t>Pelayanan yang disediakan oleh restoran, termasuk:</a:t>
+              <a:t>Pelayanan yg disediakan restoran, termasuk:</a:t>
             </a:r>
           </a:p>
           <a:p>
             <a:pPr>
               <a:spcAft>
-                <a:spcPts val="600"/>
+                <a:spcPts val="300"/>
               </a:spcAft>
               <a:defRPr sz="1600">
                 <a:solidFill>
@@ -4101,13 +4205,13 @@
               </a:defRPr>
             </a:pPr>
             <a:r>
-              <a:t>    • Roti, bakery, donat</a:t>
+              <a:t>   • Roti, bakery, donat</a:t>
             </a:r>
           </a:p>
           <a:p>
             <a:pPr>
               <a:spcAft>
-                <a:spcPts val="600"/>
+                <a:spcPts val="300"/>
               </a:spcAft>
               <a:defRPr sz="1600">
                 <a:solidFill>
@@ -4117,13 +4221,13 @@
               </a:defRPr>
             </a:pPr>
             <a:r>
-              <a:t>    • Katering &amp; jasa boga</a:t>
+              <a:t>   • Katering &amp; jasa boga</a:t>
             </a:r>
           </a:p>
           <a:p>
             <a:pPr>
               <a:spcAft>
-                <a:spcPts val="600"/>
+                <a:spcPts val="300"/>
               </a:spcAft>
               <a:defRPr sz="1600">
                 <a:solidFill>
@@ -4133,14 +4237,14 @@
               </a:defRPr>
             </a:pPr>
             <a:r>
-              <a:t>    • Usaha sejenis termasuk yang bersifat mobile/insidentil</a:t>
-            </a:r>
-          </a:p>
-        </p:txBody>
-      </p:sp>
-      <p:sp>
-        <p:nvSpPr>
-          <p:cNvPr id="7" name="Rectangle 6"/>
+              <a:t>   • Usaha sejenis — termasuk yang mobile/insidentil</a:t>
+            </a:r>
+          </a:p>
+        </p:txBody>
+      </p:sp>
+      <p:sp>
+        <p:nvSpPr>
+          <p:cNvPr id="8" name="Rectangle 7"/>
           <p:cNvSpPr/>
           <p:nvPr/>
         </p:nvSpPr>
@@ -4183,7 +4287,7 @@
       </p:sp>
       <p:sp>
         <p:nvSpPr>
-          <p:cNvPr id="8" name="TextBox 7"/>
+          <p:cNvPr id="9" name="TextBox 8"/>
           <p:cNvSpPr txBox="1"/>
           <p:nvPr/>
         </p:nvSpPr>
@@ -4212,21 +4316,21 @@
               </a:defRPr>
             </a:pPr>
             <a:r>
-              <a:t>Ayat (2)  —  Lingkup Pelayanan</a:t>
-            </a:r>
-          </a:p>
-        </p:txBody>
-      </p:sp>
-      <p:sp>
-        <p:nvSpPr>
-          <p:cNvPr id="9" name="TextBox 8"/>
+              <a:t>Ayat (2) — Lingkup Pelayanan</a:t>
+            </a:r>
+          </a:p>
+        </p:txBody>
+      </p:sp>
+      <p:sp>
+        <p:nvSpPr>
+          <p:cNvPr id="10" name="TextBox 9"/>
           <p:cNvSpPr txBox="1"/>
           <p:nvPr/>
         </p:nvSpPr>
         <p:spPr>
           <a:xfrm>
             <a:off x="640080" y="3566160"/>
-            <a:ext cx="10972800" cy="914400"/>
+            <a:ext cx="10972800" cy="731520"/>
           </a:xfrm>
           <a:prstGeom prst="rect">
             <a:avLst/>
@@ -4241,7 +4345,7 @@
           <a:p>
             <a:pPr>
               <a:spcAft>
-                <a:spcPts val="600"/>
+                <a:spcPts val="300"/>
               </a:spcAft>
               <a:defRPr sz="1600">
                 <a:solidFill>
@@ -4251,13 +4355,13 @@
               </a:defRPr>
             </a:pPr>
             <a:r>
-              <a:t>Penjualan makanan dan/atau minuman yang dikonsumsi pembeli, baik:</a:t>
+              <a:t>Penjualan makanan/minuman yg dikonsumsi pembeli:</a:t>
             </a:r>
           </a:p>
           <a:p>
             <a:pPr>
               <a:spcAft>
-                <a:spcPts val="600"/>
+                <a:spcPts val="300"/>
               </a:spcAft>
               <a:defRPr sz="1600">
                 <a:solidFill>
@@ -4267,13 +4371,13 @@
               </a:defRPr>
             </a:pPr>
             <a:r>
-              <a:t>    • Dikonsumsi di tempat pelayanan (dine-in), maupun</a:t>
+              <a:t>   • Di tempat pelayanan (dine-in)</a:t>
             </a:r>
           </a:p>
           <a:p>
             <a:pPr>
               <a:spcAft>
-                <a:spcPts val="600"/>
+                <a:spcPts val="300"/>
               </a:spcAft>
               <a:defRPr sz="1600">
                 <a:solidFill>
@@ -4283,20 +4387,20 @@
               </a:defRPr>
             </a:pPr>
             <a:r>
-              <a:t>    • Dikonsumsi di tempat lain (takeaway/delivery)</a:t>
-            </a:r>
-          </a:p>
-        </p:txBody>
-      </p:sp>
-      <p:sp>
-        <p:nvSpPr>
-          <p:cNvPr id="10" name="Rectangle 9"/>
+              <a:t>   • Di tempat lain (takeaway/delivery)</a:t>
+            </a:r>
+          </a:p>
+        </p:txBody>
+      </p:sp>
+      <p:sp>
+        <p:nvSpPr>
+          <p:cNvPr id="11" name="Rectangle 10"/>
           <p:cNvSpPr/>
           <p:nvPr/>
         </p:nvSpPr>
         <p:spPr>
           <a:xfrm>
-            <a:off x="457200" y="4572000"/>
+            <a:off x="457200" y="4389120"/>
             <a:ext cx="11247120" cy="1371600"/>
           </a:xfrm>
           <a:prstGeom prst="rect">
@@ -4333,13 +4437,13 @@
       </p:sp>
       <p:sp>
         <p:nvSpPr>
-          <p:cNvPr id="11" name="Rectangle 10"/>
+          <p:cNvPr id="12" name="Rectangle 11"/>
           <p:cNvSpPr/>
           <p:nvPr/>
         </p:nvSpPr>
         <p:spPr>
           <a:xfrm>
-            <a:off x="457200" y="4572000"/>
+            <a:off x="457200" y="4389120"/>
             <a:ext cx="137160" cy="1371600"/>
           </a:xfrm>
           <a:prstGeom prst="rect">
@@ -4376,14 +4480,14 @@
       </p:sp>
       <p:sp>
         <p:nvSpPr>
-          <p:cNvPr id="12" name="TextBox 11"/>
+          <p:cNvPr id="13" name="TextBox 12"/>
           <p:cNvSpPr txBox="1"/>
           <p:nvPr/>
         </p:nvSpPr>
         <p:spPr>
           <a:xfrm>
-            <a:off x="822960" y="4663440"/>
-            <a:ext cx="10515600" cy="457200"/>
+            <a:off x="822960" y="4480560"/>
+            <a:ext cx="10515600" cy="365760"/>
           </a:xfrm>
           <a:prstGeom prst="rect">
             <a:avLst/>
@@ -4405,21 +4509,21 @@
               </a:defRPr>
             </a:pPr>
             <a:r>
-              <a:t>❖  PENGECUALIAN</a:t>
-            </a:r>
-          </a:p>
-        </p:txBody>
-      </p:sp>
-      <p:sp>
-        <p:nvSpPr>
-          <p:cNvPr id="13" name="TextBox 12"/>
+              <a:t>PENGECUALIAN</a:t>
+            </a:r>
+          </a:p>
+        </p:txBody>
+      </p:sp>
+      <p:sp>
+        <p:nvSpPr>
+          <p:cNvPr id="14" name="TextBox 13"/>
           <p:cNvSpPr txBox="1"/>
           <p:nvPr/>
         </p:nvSpPr>
         <p:spPr>
           <a:xfrm>
-            <a:off x="822960" y="5120640"/>
-            <a:ext cx="10515600" cy="731520"/>
+            <a:off x="822960" y="4937760"/>
+            <a:ext cx="10515600" cy="640080"/>
           </a:xfrm>
           <a:prstGeom prst="rect">
             <a:avLst/>
@@ -4433,7 +4537,7 @@
           <a:lstStyle/>
           <a:p>
             <a:pPr algn="l">
-              <a:defRPr sz="1800" b="0">
+              <a:defRPr sz="2000" b="1">
                 <a:solidFill>
                   <a:srgbClr val="665000"/>
                 </a:solidFill>
@@ -4441,18 +4545,14 @@
               </a:defRPr>
             </a:pPr>
             <a:r>
-              <a:t>Ayat (3): Pelayanan penjualan makanan/minuman dengan omzet ≤ Rp 10.000.000/bulan</a:t>
-            </a:r>
-            <a:br/>
-            <a:r>
-              <a:t>TIDAK termasuk objek pajak.</a:t>
-            </a:r>
-          </a:p>
-        </p:txBody>
-      </p:sp>
-      <p:sp>
-        <p:nvSpPr>
-          <p:cNvPr id="14" name="Rectangle 13"/>
+              <a:t>Ayat (3): Omzet ≤ Rp 10.000.000/bulan → BUKAN objek pajak</a:t>
+            </a:r>
+          </a:p>
+        </p:txBody>
+      </p:sp>
+      <p:sp>
+        <p:nvSpPr>
+          <p:cNvPr id="15" name="Rectangle 14"/>
           <p:cNvSpPr/>
           <p:nvPr/>
         </p:nvSpPr>
@@ -4495,7 +4595,7 @@
       </p:sp>
       <p:sp>
         <p:nvSpPr>
-          <p:cNvPr id="15" name="TextBox 14"/>
+          <p:cNvPr id="16" name="TextBox 15"/>
           <p:cNvSpPr txBox="1"/>
           <p:nvPr/>
         </p:nvSpPr>
@@ -4598,16 +4698,40 @@
           </a:p>
         </p:txBody>
       </p:sp>
-      <p:sp>
-        <p:nvSpPr>
-          <p:cNvPr id="3" name="TextBox 2"/>
+      <p:pic>
+        <p:nvPicPr>
+          <p:cNvPr id="3" name="Picture 2" descr="logo_bekasi.png"/>
+          <p:cNvPicPr>
+            <a:picLocks noChangeAspect="1"/>
+          </p:cNvPicPr>
+          <p:nvPr/>
+        </p:nvPicPr>
+        <p:blipFill>
+          <a:blip r:embed="rId2"/>
+          <a:stretch>
+            <a:fillRect/>
+          </a:stretch>
+        </p:blipFill>
+        <p:spPr>
+          <a:xfrm>
+            <a:off x="274320" y="91440"/>
+            <a:ext cx="548740" cy="640080"/>
+          </a:xfrm>
+          <a:prstGeom prst="rect">
+            <a:avLst/>
+          </a:prstGeom>
+        </p:spPr>
+      </p:pic>
+      <p:sp>
+        <p:nvSpPr>
+          <p:cNvPr id="4" name="TextBox 3"/>
           <p:cNvSpPr txBox="1"/>
           <p:nvPr/>
         </p:nvSpPr>
         <p:spPr>
           <a:xfrm>
-            <a:off x="457200" y="137160"/>
-            <a:ext cx="10972800" cy="640080"/>
+            <a:off x="1188720" y="137160"/>
+            <a:ext cx="10058400" cy="640080"/>
           </a:xfrm>
           <a:prstGeom prst="rect">
             <a:avLst/>
@@ -4629,14 +4753,14 @@
               </a:defRPr>
             </a:pPr>
             <a:r>
-              <a:t>PASAL II — PENUTUP &amp; INFORMASI PENGESAHAN</a:t>
-            </a:r>
-          </a:p>
-        </p:txBody>
-      </p:sp>
-      <p:sp>
-        <p:nvSpPr>
-          <p:cNvPr id="4" name="Rectangle 3"/>
+              <a:t>PASAL II &amp; INFORMASI PENGESAHAN</a:t>
+            </a:r>
+          </a:p>
+        </p:txBody>
+      </p:sp>
+      <p:sp>
+        <p:nvSpPr>
+          <p:cNvPr id="5" name="Rectangle 4"/>
           <p:cNvSpPr/>
           <p:nvPr/>
         </p:nvSpPr>
@@ -4679,7 +4803,7 @@
       </p:sp>
       <p:sp>
         <p:nvSpPr>
-          <p:cNvPr id="5" name="TextBox 4"/>
+          <p:cNvPr id="6" name="TextBox 5"/>
           <p:cNvSpPr txBox="1"/>
           <p:nvPr/>
         </p:nvSpPr>
@@ -4715,14 +4839,14 @@
       </p:sp>
       <p:sp>
         <p:nvSpPr>
-          <p:cNvPr id="6" name="TextBox 5"/>
+          <p:cNvPr id="7" name="TextBox 6"/>
           <p:cNvSpPr txBox="1"/>
           <p:nvPr/>
         </p:nvSpPr>
         <p:spPr>
           <a:xfrm>
             <a:off x="640080" y="1828800"/>
-            <a:ext cx="5029200" cy="914400"/>
+            <a:ext cx="5029200" cy="731520"/>
           </a:xfrm>
           <a:prstGeom prst="rect">
             <a:avLst/>
@@ -4755,7 +4879,7 @@
       </p:sp>
       <p:sp>
         <p:nvSpPr>
-          <p:cNvPr id="7" name="Rectangle 6"/>
+          <p:cNvPr id="8" name="Rectangle 7"/>
           <p:cNvSpPr/>
           <p:nvPr/>
         </p:nvSpPr>
@@ -4798,7 +4922,7 @@
       </p:sp>
       <p:sp>
         <p:nvSpPr>
-          <p:cNvPr id="8" name="TextBox 7"/>
+          <p:cNvPr id="9" name="TextBox 8"/>
           <p:cNvSpPr txBox="1"/>
           <p:nvPr/>
         </p:nvSpPr>
@@ -4834,7 +4958,7 @@
       </p:sp>
       <p:sp>
         <p:nvSpPr>
-          <p:cNvPr id="9" name="TextBox 8"/>
+          <p:cNvPr id="10" name="TextBox 9"/>
           <p:cNvSpPr txBox="1"/>
           <p:nvPr/>
         </p:nvSpPr>
@@ -4856,7 +4980,7 @@
           <a:p>
             <a:pPr>
               <a:spcAft>
-                <a:spcPts val="600"/>
+                <a:spcPts val="300"/>
               </a:spcAft>
               <a:defRPr sz="1500">
                 <a:solidFill>
@@ -4866,13 +4990,13 @@
               </a:defRPr>
             </a:pPr>
             <a:r>
-              <a:t>Ditandatangani: 3 Desember 2018</a:t>
+              <a:t>Tanggal: 3 Desember 2018</a:t>
             </a:r>
           </a:p>
           <a:p>
             <a:pPr>
               <a:spcAft>
-                <a:spcPts val="600"/>
+                <a:spcPts val="300"/>
               </a:spcAft>
               <a:defRPr sz="1500">
                 <a:solidFill>
@@ -4882,13 +5006,13 @@
               </a:defRPr>
             </a:pPr>
             <a:r>
-              <a:t>Wali Kota Bekasi: Rahmat Effendi</a:t>
+              <a:t>Wali Kota: Rahmat Effendi</a:t>
             </a:r>
           </a:p>
           <a:p>
             <a:pPr>
               <a:spcAft>
-                <a:spcPts val="600"/>
+                <a:spcPts val="300"/>
               </a:spcAft>
               <a:defRPr sz="1500">
                 <a:solidFill>
@@ -4898,13 +5022,13 @@
               </a:defRPr>
             </a:pPr>
             <a:r>
-              <a:t>Pj. Sekretaris Daerah: Widodo Indrijantoro</a:t>
+              <a:t>Pj. Sekda: Widodo Indrijantoro</a:t>
             </a:r>
           </a:p>
           <a:p>
             <a:pPr>
               <a:spcAft>
-                <a:spcPts val="600"/>
+                <a:spcPts val="300"/>
               </a:spcAft>
               <a:defRPr sz="1500">
                 <a:solidFill>
@@ -4914,13 +5038,13 @@
               </a:defRPr>
             </a:pPr>
             <a:r>
-              <a:t>Disetujui DPRD Kota Bekasi &amp; Wali Kota</a:t>
+              <a:t>Disetujui DPRD &amp; Wali Kota Bekasi</a:t>
             </a:r>
           </a:p>
           <a:p>
             <a:pPr>
               <a:spcAft>
-                <a:spcPts val="600"/>
+                <a:spcPts val="300"/>
               </a:spcAft>
               <a:defRPr sz="1500">
                 <a:solidFill>
@@ -4930,13 +5054,13 @@
               </a:defRPr>
             </a:pPr>
             <a:r>
-              <a:t>Diundangkan di Bekasi, 3 Desember 2018</a:t>
+              <a:t>Diundangkan: 3 Desember 2018</a:t>
             </a:r>
           </a:p>
           <a:p>
             <a:pPr>
               <a:spcAft>
-                <a:spcPts val="600"/>
+                <a:spcPts val="300"/>
               </a:spcAft>
               <a:defRPr sz="1500">
                 <a:solidFill>
@@ -4952,7 +5076,7 @@
           <a:p>
             <a:pPr>
               <a:spcAft>
-                <a:spcPts val="600"/>
+                <a:spcPts val="300"/>
               </a:spcAft>
               <a:defRPr sz="1500">
                 <a:solidFill>
@@ -4962,14 +5086,14 @@
               </a:defRPr>
             </a:pPr>
             <a:r>
-              <a:t>LEMBARAN DAERAH Seri B No. 14/2018</a:t>
-            </a:r>
-          </a:p>
-        </p:txBody>
-      </p:sp>
-      <p:sp>
-        <p:nvSpPr>
-          <p:cNvPr id="10" name="Rectangle 9"/>
+              <a:t>Lembaran Daerah Seri B No. 14/2018</a:t>
+            </a:r>
+          </a:p>
+        </p:txBody>
+      </p:sp>
+      <p:sp>
+        <p:nvSpPr>
+          <p:cNvPr id="11" name="Rectangle 10"/>
           <p:cNvSpPr/>
           <p:nvPr/>
         </p:nvSpPr>
@@ -5012,7 +5136,7 @@
       </p:sp>
       <p:sp>
         <p:nvSpPr>
-          <p:cNvPr id="11" name="TextBox 10"/>
+          <p:cNvPr id="12" name="TextBox 11"/>
           <p:cNvSpPr txBox="1"/>
           <p:nvPr/>
         </p:nvSpPr>
@@ -5048,7 +5172,7 @@
       </p:sp>
       <p:sp>
         <p:nvSpPr>
-          <p:cNvPr id="12" name="TextBox 11"/>
+          <p:cNvPr id="13" name="TextBox 12"/>
           <p:cNvSpPr txBox="1"/>
           <p:nvPr/>
         </p:nvSpPr>
@@ -5070,7 +5194,7 @@
           <a:p>
             <a:pPr>
               <a:spcAft>
-                <a:spcPts val="800"/>
+                <a:spcPts val="600"/>
               </a:spcAft>
               <a:defRPr sz="1600">
                 <a:solidFill>
@@ -5080,13 +5204,13 @@
               </a:defRPr>
             </a:pPr>
             <a:r>
-              <a:t>1. Memperluas objek pajak restoran (katering, bakery, mobile/insidentil, dll)</a:t>
+              <a:t>1. Memperluas objek pajak restoran (katering, bakery, mobile, dsb)</a:t>
             </a:r>
           </a:p>
           <a:p>
             <a:pPr>
               <a:spcAft>
-                <a:spcPts val="800"/>
+                <a:spcPts val="600"/>
               </a:spcAft>
               <a:defRPr sz="1600">
                 <a:solidFill>
@@ -5096,13 +5220,13 @@
               </a:defRPr>
             </a:pPr>
             <a:r>
-              <a:t>2. Menegaskan lingkup pelayanan: dine-in &amp; takeaway/delivery</a:t>
+              <a:t>2. Menegaskan lingkup: dine-in &amp; takeaway/delivery</a:t>
             </a:r>
           </a:p>
           <a:p>
             <a:pPr>
               <a:spcAft>
-                <a:spcPts val="800"/>
+                <a:spcPts val="600"/>
               </a:spcAft>
               <a:defRPr sz="1600">
                 <a:solidFill>
@@ -5112,13 +5236,13 @@
               </a:defRPr>
             </a:pPr>
             <a:r>
-              <a:t>3. Memberikan pengecualian: omzet ≤ Rp 10 jt/bulan tidak kena pajak</a:t>
+              <a:t>3. Pengecualian: omzet ≤ Rp 10 jt/bulan → bebas pajak</a:t>
             </a:r>
           </a:p>
           <a:p>
             <a:pPr>
               <a:spcAft>
-                <a:spcPts val="800"/>
+                <a:spcPts val="600"/>
               </a:spcAft>
               <a:defRPr sz="1600">
                 <a:solidFill>
@@ -5128,14 +5252,14 @@
               </a:defRPr>
             </a:pPr>
             <a:r>
-              <a:t>4. Perubahan hanya pada Pasal 3 — pasal lain tidak diubah</a:t>
-            </a:r>
-          </a:p>
-        </p:txBody>
-      </p:sp>
-      <p:sp>
-        <p:nvSpPr>
-          <p:cNvPr id="13" name="Rectangle 12"/>
+              <a:t>4. Hanya Pasal 3 yg diubah — pasal lain tetap</a:t>
+            </a:r>
+          </a:p>
+        </p:txBody>
+      </p:sp>
+      <p:sp>
+        <p:nvSpPr>
+          <p:cNvPr id="14" name="Rectangle 13"/>
           <p:cNvSpPr/>
           <p:nvPr/>
         </p:nvSpPr>
@@ -5178,7 +5302,7 @@
       </p:sp>
       <p:sp>
         <p:nvSpPr>
-          <p:cNvPr id="14" name="TextBox 13"/>
+          <p:cNvPr id="15" name="TextBox 14"/>
           <p:cNvSpPr txBox="1"/>
           <p:nvPr/>
         </p:nvSpPr>
@@ -5207,7 +5331,7 @@
               </a:defRPr>
             </a:pPr>
             <a:r>
-              <a:t>Sumber: https://jdih.bekasikota.go.id/storage/peraturan/1765169210737-354909996.pdf</a:t>
+              <a:t>Sumber: jdih.bekasikota.go.id</a:t>
             </a:r>
           </a:p>
         </p:txBody>
@@ -5246,7 +5370,7 @@
         </p:nvSpPr>
         <p:spPr>
           <a:xfrm>
-            <a:off x="0" y="2560320"/>
+            <a:off x="0" y="2286000"/>
             <a:ext cx="12191695" cy="54864"/>
           </a:xfrm>
           <a:prstGeom prst="rect">
@@ -5289,7 +5413,7 @@
         </p:nvSpPr>
         <p:spPr>
           <a:xfrm>
-            <a:off x="0" y="4206240"/>
+            <a:off x="0" y="4572000"/>
             <a:ext cx="12191695" cy="54864"/>
           </a:xfrm>
           <a:prstGeom prst="rect">
@@ -5324,16 +5448,40 @@
           </a:p>
         </p:txBody>
       </p:sp>
-      <p:sp>
-        <p:nvSpPr>
-          <p:cNvPr id="4" name="TextBox 3"/>
+      <p:pic>
+        <p:nvPicPr>
+          <p:cNvPr id="4" name="Picture 3" descr="logo_bekasi.png"/>
+          <p:cNvPicPr>
+            <a:picLocks noChangeAspect="1"/>
+          </p:cNvPicPr>
+          <p:nvPr/>
+        </p:nvPicPr>
+        <p:blipFill>
+          <a:blip r:embed="rId2"/>
+          <a:stretch>
+            <a:fillRect/>
+          </a:stretch>
+        </p:blipFill>
+        <p:spPr>
+          <a:xfrm>
+            <a:off x="5120640" y="731520"/>
+            <a:ext cx="1411047" cy="1645920"/>
+          </a:xfrm>
+          <a:prstGeom prst="rect">
+            <a:avLst/>
+          </a:prstGeom>
+        </p:spPr>
+      </p:pic>
+      <p:sp>
+        <p:nvSpPr>
+          <p:cNvPr id="5" name="TextBox 4"/>
           <p:cNvSpPr txBox="1"/>
           <p:nvPr/>
         </p:nvSpPr>
         <p:spPr>
           <a:xfrm>
-            <a:off x="914400" y="1828800"/>
-            <a:ext cx="10058400" cy="1097280"/>
+            <a:off x="914400" y="2560320"/>
+            <a:ext cx="10058400" cy="914400"/>
           </a:xfrm>
           <a:prstGeom prst="rect">
             <a:avLst/>
@@ -5362,13 +5510,13 @@
       </p:sp>
       <p:sp>
         <p:nvSpPr>
-          <p:cNvPr id="5" name="TextBox 4"/>
+          <p:cNvPr id="6" name="TextBox 5"/>
           <p:cNvSpPr txBox="1"/>
           <p:nvPr/>
         </p:nvSpPr>
         <p:spPr>
           <a:xfrm>
-            <a:off x="914400" y="3017520"/>
+            <a:off x="914400" y="3474720"/>
             <a:ext cx="10058400" cy="914400"/>
           </a:xfrm>
           <a:prstGeom prst="rect">
@@ -5383,7 +5531,7 @@
           <a:lstStyle/>
           <a:p>
             <a:pPr algn="ctr">
-              <a:defRPr sz="2000" b="0">
+              <a:defRPr sz="1800" b="0">
                 <a:solidFill>
                   <a:srgbClr val="CCDDEE"/>
                 </a:solidFill>
@@ -5402,13 +5550,13 @@
       </p:sp>
       <p:sp>
         <p:nvSpPr>
-          <p:cNvPr id="6" name="TextBox 5"/>
+          <p:cNvPr id="7" name="TextBox 6"/>
           <p:cNvSpPr txBox="1"/>
           <p:nvPr/>
         </p:nvSpPr>
         <p:spPr>
           <a:xfrm>
-            <a:off x="914400" y="4572000"/>
+            <a:off x="914400" y="4846320"/>
             <a:ext cx="10058400" cy="457200"/>
           </a:xfrm>
           <a:prstGeom prst="rect">

</xml_diff>

<commit_message>
fix: perbesar logo Kota Bekasi di semua slide
</commit_message>
<xml_diff>
--- a/Ringkasan_Perda_Bekasi_No_14_2018.pptx
+++ b/Ringkasan_Perda_Bekasi_No_14_2018.pptx
@@ -3108,8 +3108,8 @@
         </p:nvSpPr>
         <p:spPr>
           <a:xfrm>
-            <a:off x="0" y="2560320"/>
-            <a:ext cx="12191695" cy="54864"/>
+            <a:off x="0" y="2011680"/>
+            <a:ext cx="12191695" cy="36576"/>
           </a:xfrm>
           <a:prstGeom prst="rect">
             <a:avLst/>
@@ -3151,8 +3151,8 @@
         </p:nvSpPr>
         <p:spPr>
           <a:xfrm>
-            <a:off x="0" y="4206240"/>
-            <a:ext cx="12191695" cy="54864"/>
+            <a:off x="0" y="4572000"/>
+            <a:ext cx="12191695" cy="36576"/>
           </a:xfrm>
           <a:prstGeom prst="rect">
             <a:avLst/>
@@ -3202,8 +3202,8 @@
         </p:blipFill>
         <p:spPr>
           <a:xfrm>
-            <a:off x="5303520" y="548640"/>
-            <a:ext cx="1254264" cy="1463040"/>
+            <a:off x="5029200" y="365760"/>
+            <a:ext cx="1724613" cy="2011680"/>
           </a:xfrm>
           <a:prstGeom prst="rect">
             <a:avLst/>
@@ -3218,8 +3218,8 @@
         </p:nvSpPr>
         <p:spPr>
           <a:xfrm>
-            <a:off x="914400" y="914400"/>
-            <a:ext cx="10058400" cy="548640"/>
+            <a:off x="914400" y="2286000"/>
+            <a:ext cx="10058400" cy="640080"/>
           </a:xfrm>
           <a:prstGeom prst="rect">
             <a:avLst/>
@@ -3233,15 +3233,15 @@
           <a:lstStyle/>
           <a:p>
             <a:pPr algn="ctr">
-              <a:defRPr sz="2000" b="0">
-                <a:solidFill>
-                  <a:srgbClr val="AACCEE"/>
+              <a:defRPr sz="2200" b="1">
+                <a:solidFill>
+                  <a:srgbClr val="CCDDEE"/>
                 </a:solidFill>
                 <a:latin typeface="Calibri"/>
               </a:defRPr>
             </a:pPr>
             <a:r>
-              <a:t>RINGKASAN PERATURAN DAERAH</a:t>
+              <a:t>PEMERINTAH KOTA BEKASI</a:t>
             </a:r>
           </a:p>
         </p:txBody>
@@ -3254,8 +3254,8 @@
         </p:nvSpPr>
         <p:spPr>
           <a:xfrm>
-            <a:off x="914400" y="2743200"/>
-            <a:ext cx="10058400" cy="1280160"/>
+            <a:off x="914400" y="2926080"/>
+            <a:ext cx="10058400" cy="1097280"/>
           </a:xfrm>
           <a:prstGeom prst="rect">
             <a:avLst/>
@@ -3269,7 +3269,7 @@
           <a:lstStyle/>
           <a:p>
             <a:pPr algn="ctr">
-              <a:defRPr sz="4200" b="1">
+              <a:defRPr sz="3800" b="1">
                 <a:solidFill>
                   <a:srgbClr val="FFFFFF"/>
                 </a:solidFill>
@@ -3277,11 +3277,11 @@
               </a:defRPr>
             </a:pPr>
             <a:r>
-              <a:t>KOTA BEKASI</a:t>
+              <a:t>RINGKASAN PERATURAN DAERAH</a:t>
             </a:r>
             <a:br/>
             <a:r>
-              <a:t>NOMOR 14 TAHUN 2018</a:t>
+              <a:t>KOTA BEKASI NOMOR 14 TAHUN 2018</a:t>
             </a:r>
           </a:p>
         </p:txBody>
@@ -3294,8 +3294,8 @@
         </p:nvSpPr>
         <p:spPr>
           <a:xfrm>
-            <a:off x="914400" y="4389120"/>
-            <a:ext cx="10058400" cy="731520"/>
+            <a:off x="1371600" y="4023360"/>
+            <a:ext cx="9144000" cy="640080"/>
           </a:xfrm>
           <a:prstGeom prst="rect">
             <a:avLst/>
@@ -3309,19 +3309,19 @@
           <a:lstStyle/>
           <a:p>
             <a:pPr algn="ctr">
-              <a:defRPr sz="2000" b="0">
-                <a:solidFill>
-                  <a:srgbClr val="CCDDEE"/>
+              <a:defRPr sz="1800" b="0">
+                <a:solidFill>
+                  <a:srgbClr val="AACCEE"/>
                 </a:solidFill>
                 <a:latin typeface="Calibri"/>
               </a:defRPr>
             </a:pPr>
             <a:r>
-              <a:t>Perubahan Atas Peraturan Daerah Kota Bekasi</a:t>
+              <a:t>Perubahan Atas Peraturan Daerah Kota Bekasi Nomor 08 Tahun 2011</a:t>
             </a:r>
             <a:br/>
             <a:r>
-              <a:t>Nomor 08 Tahun 2011 Tentang Pajak Restoran</a:t>
+              <a:t>Tentang Pajak Restoran</a:t>
             </a:r>
           </a:p>
         </p:txBody>
@@ -3334,7 +3334,7 @@
         </p:nvSpPr>
         <p:spPr>
           <a:xfrm>
-            <a:off x="914400" y="5760720"/>
+            <a:off x="914400" y="4846320"/>
             <a:ext cx="10058400" cy="457200"/>
           </a:xfrm>
           <a:prstGeom prst="rect">
@@ -3357,7 +3357,7 @@
               </a:defRPr>
             </a:pPr>
             <a:r>
-              <a:t>LEMBARAN DAERAH KOTA BEKASI — SERI B NOMOR 14 — 2018</a:t>
+              <a:t>LEMBARAN DAERAH KOTA BEKASI  •  SERI B  •  NOMOR 14  •  2018</a:t>
             </a:r>
           </a:p>
         </p:txBody>
@@ -3447,8 +3447,8 @@
         </p:blipFill>
         <p:spPr>
           <a:xfrm>
-            <a:off x="274320" y="91440"/>
-            <a:ext cx="548740" cy="640080"/>
+            <a:off x="457200" y="45720"/>
+            <a:ext cx="705523" cy="822960"/>
           </a:xfrm>
           <a:prstGeom prst="rect">
             <a:avLst/>
@@ -3463,8 +3463,8 @@
         </p:nvSpPr>
         <p:spPr>
           <a:xfrm>
-            <a:off x="1188720" y="137160"/>
-            <a:ext cx="10058400" cy="640080"/>
+            <a:off x="1554480" y="137160"/>
+            <a:ext cx="9144000" cy="640080"/>
           </a:xfrm>
           <a:prstGeom prst="rect">
             <a:avLst/>
@@ -3500,7 +3500,7 @@
         <p:spPr>
           <a:xfrm>
             <a:off x="457200" y="1188720"/>
-            <a:ext cx="5486400" cy="548640"/>
+            <a:ext cx="5303520" cy="502920"/>
           </a:xfrm>
           <a:prstGeom prst="rect">
             <a:avLst/>
@@ -3543,7 +3543,7 @@
         <p:spPr>
           <a:xfrm>
             <a:off x="640080" y="1234440"/>
-            <a:ext cx="5029200" cy="457200"/>
+            <a:ext cx="4937760" cy="457200"/>
           </a:xfrm>
           <a:prstGeom prst="rect">
             <a:avLst/>
@@ -3565,7 +3565,7 @@
               </a:defRPr>
             </a:pPr>
             <a:r>
-              <a:t>▸  LATAR BELAKANG</a:t>
+              <a:t>LATAR BELAKANG</a:t>
             </a:r>
           </a:p>
         </p:txBody>
@@ -3578,8 +3578,8 @@
         </p:nvSpPr>
         <p:spPr>
           <a:xfrm>
-            <a:off x="640080" y="1920240"/>
-            <a:ext cx="5029200" cy="4114800"/>
+            <a:off x="640080" y="1828800"/>
+            <a:ext cx="4937760" cy="1828800"/>
           </a:xfrm>
           <a:prstGeom prst="rect">
             <a:avLst/>
@@ -3604,7 +3604,7 @@
               </a:defRPr>
             </a:pPr>
             <a:r>
-              <a:t>Mengoptimalkan &amp; meningkatkan Pendapatan</a:t>
+              <a:t>►  Mengoptimalkan Pendapatan Asli Daerah (PAD)</a:t>
             </a:r>
           </a:p>
           <a:p>
@@ -3620,7 +3620,7 @@
               </a:defRPr>
             </a:pPr>
             <a:r>
-              <a:t>Asli Daerah (PAD) dari Pajak Restoran</a:t>
+              <a:t>     dari sektor Pajak Restoran</a:t>
             </a:r>
           </a:p>
           <a:p>
@@ -3635,6 +3635,9 @@
                 <a:latin typeface="Calibri"/>
               </a:defRPr>
             </a:pPr>
+            <a:r>
+              <a:t>►  Menyesuaikan Perda No. 08/2011 dengan</a:t>
+            </a:r>
           </a:p>
           <a:p>
             <a:pPr>
@@ -3649,23 +3652,7 @@
               </a:defRPr>
             </a:pPr>
             <a:r>
-              <a:t>Menyesuaikan Perda No. 08/2011 dengan</a:t>
-            </a:r>
-          </a:p>
-          <a:p>
-            <a:pPr>
-              <a:spcAft>
-                <a:spcPts val="400"/>
-              </a:spcAft>
-              <a:defRPr sz="1600">
-                <a:solidFill>
-                  <a:srgbClr val="2D2D2D"/>
-                </a:solidFill>
-                <a:latin typeface="Calibri"/>
-              </a:defRPr>
-            </a:pPr>
-            <a:r>
-              <a:t>kondisi terkini</a:t>
+              <a:t>     kondisi perekonomian terkini</a:t>
             </a:r>
           </a:p>
         </p:txBody>
@@ -3679,7 +3666,7 @@
         <p:spPr>
           <a:xfrm>
             <a:off x="6217920" y="1188720"/>
-            <a:ext cx="5486400" cy="548640"/>
+            <a:ext cx="5486400" cy="502920"/>
           </a:xfrm>
           <a:prstGeom prst="rect">
             <a:avLst/>
@@ -3722,7 +3709,7 @@
         <p:spPr>
           <a:xfrm>
             <a:off x="6400800" y="1234440"/>
-            <a:ext cx="5029200" cy="457200"/>
+            <a:ext cx="5120640" cy="457200"/>
           </a:xfrm>
           <a:prstGeom prst="rect">
             <a:avLst/>
@@ -3744,7 +3731,7 @@
               </a:defRPr>
             </a:pPr>
             <a:r>
-              <a:t>▸  DASAR HUKUM UTAMA</a:t>
+              <a:t>DASAR HUKUM UTAMA</a:t>
             </a:r>
           </a:p>
         </p:txBody>
@@ -3757,8 +3744,8 @@
         </p:nvSpPr>
         <p:spPr>
           <a:xfrm>
-            <a:off x="6400800" y="1920240"/>
-            <a:ext cx="5303520" cy="4114800"/>
+            <a:off x="6400800" y="1828800"/>
+            <a:ext cx="5120640" cy="2743200"/>
           </a:xfrm>
           <a:prstGeom prst="rect">
             <a:avLst/>
@@ -3773,7 +3760,7 @@
           <a:p>
             <a:pPr>
               <a:spcAft>
-                <a:spcPts val="300"/>
+                <a:spcPts val="400"/>
               </a:spcAft>
               <a:defRPr sz="1400">
                 <a:solidFill>
@@ -3783,13 +3770,13 @@
               </a:defRPr>
             </a:pPr>
             <a:r>
-              <a:t>UU No. 28/2009 — Pajak Daerah &amp; Retribusi</a:t>
+              <a:t>•  UU No. 28/2009 — Pajak Daerah &amp; Retribusi Daerah</a:t>
             </a:r>
           </a:p>
           <a:p>
             <a:pPr>
               <a:spcAft>
-                <a:spcPts val="300"/>
+                <a:spcPts val="400"/>
               </a:spcAft>
               <a:defRPr sz="1400">
                 <a:solidFill>
@@ -3799,13 +3786,13 @@
               </a:defRPr>
             </a:pPr>
             <a:r>
-              <a:t>UU No. 23/2014 — Pemerintahan Daerah</a:t>
+              <a:t>•  UU No. 23/2014 — Pemerintahan Daerah</a:t>
             </a:r>
           </a:p>
           <a:p>
             <a:pPr>
               <a:spcAft>
-                <a:spcPts val="300"/>
+                <a:spcPts val="400"/>
               </a:spcAft>
               <a:defRPr sz="1400">
                 <a:solidFill>
@@ -3815,13 +3802,13 @@
               </a:defRPr>
             </a:pPr>
             <a:r>
-              <a:t>UU No. 6/1983 jo. UU 16/2009 — Ketentuan Perpajakan</a:t>
+              <a:t>•  UU No. 6/1983 jo. UU 16/2009 — Ketentuan Perpajakan</a:t>
             </a:r>
           </a:p>
           <a:p>
             <a:pPr>
               <a:spcAft>
-                <a:spcPts val="300"/>
+                <a:spcPts val="400"/>
               </a:spcAft>
               <a:defRPr sz="1400">
                 <a:solidFill>
@@ -3831,13 +3818,13 @@
               </a:defRPr>
             </a:pPr>
             <a:r>
-              <a:t>PP No. 55/2016 — Pemungutan Pajak Daerah</a:t>
+              <a:t>•  PP No. 55/2016 — Pemungutan Pajak Daerah</a:t>
             </a:r>
           </a:p>
           <a:p>
             <a:pPr>
               <a:spcAft>
-                <a:spcPts val="300"/>
+                <a:spcPts val="400"/>
               </a:spcAft>
               <a:defRPr sz="1400">
                 <a:solidFill>
@@ -3847,13 +3834,13 @@
               </a:defRPr>
             </a:pPr>
             <a:r>
-              <a:t>PP No. 69/2010 — Insentif Pajak Daerah</a:t>
+              <a:t>•  PP No. 69/2010 — Insentif Pajak Daerah</a:t>
             </a:r>
           </a:p>
           <a:p>
             <a:pPr>
               <a:spcAft>
-                <a:spcPts val="300"/>
+                <a:spcPts val="400"/>
               </a:spcAft>
               <a:defRPr sz="1400">
                 <a:solidFill>
@@ -3863,7 +3850,7 @@
               </a:defRPr>
             </a:pPr>
             <a:r>
-              <a:t>Perda Kota Bekasi No. 08/2011 — Pajak Restoran</a:t>
+              <a:t>•  Perda Kota Bekasi No. 08/2011 — Pajak Restoran</a:t>
             </a:r>
           </a:p>
         </p:txBody>
@@ -3942,7 +3929,7 @@
               </a:defRPr>
             </a:pPr>
             <a:r>
-              <a:t>Perda No. 14/2018 — Perubahan Perda No. 08/2011 tentang Pajak Restoran</a:t>
+              <a:t>Perda No. 14/2018 — Perubahan Atas Perda No. 08/2011 tentang Pajak Restoran</a:t>
             </a:r>
           </a:p>
         </p:txBody>
@@ -4032,8 +4019,8 @@
         </p:blipFill>
         <p:spPr>
           <a:xfrm>
-            <a:off x="274320" y="91440"/>
-            <a:ext cx="548740" cy="640080"/>
+            <a:off x="457200" y="45720"/>
+            <a:ext cx="705523" cy="822960"/>
           </a:xfrm>
           <a:prstGeom prst="rect">
             <a:avLst/>
@@ -4048,8 +4035,8 @@
         </p:nvSpPr>
         <p:spPr>
           <a:xfrm>
-            <a:off x="1188720" y="137160"/>
-            <a:ext cx="10058400" cy="640080"/>
+            <a:off x="1554480" y="137160"/>
+            <a:ext cx="9144000" cy="640080"/>
           </a:xfrm>
           <a:prstGeom prst="rect">
             <a:avLst/>
@@ -4071,7 +4058,7 @@
               </a:defRPr>
             </a:pPr>
             <a:r>
-              <a:t>PASAL I — PERUBAHAN UTAMA: OBJEK PAJAK</a:t>
+              <a:t>PASAL I — PERUBAHAN OBJEK PAJAK RESTORAN</a:t>
             </a:r>
           </a:p>
         </p:txBody>
@@ -4128,7 +4115,7 @@
         <p:spPr>
           <a:xfrm>
             <a:off x="640080" y="1207008"/>
-            <a:ext cx="10972800" cy="457200"/>
+            <a:ext cx="10058400" cy="457200"/>
           </a:xfrm>
           <a:prstGeom prst="rect">
             <a:avLst/>
@@ -4150,7 +4137,7 @@
               </a:defRPr>
             </a:pPr>
             <a:r>
-              <a:t>Ayat (1) — Objek Pajak Restoran (diperluas)</a:t>
+              <a:t>Ayat (1) —  Perluasan Objek Pajak</a:t>
             </a:r>
           </a:p>
         </p:txBody>
@@ -4164,7 +4151,7 @@
         <p:spPr>
           <a:xfrm>
             <a:off x="640080" y="1737360"/>
-            <a:ext cx="10972800" cy="1371600"/>
+            <a:ext cx="10515600" cy="1188720"/>
           </a:xfrm>
           <a:prstGeom prst="rect">
             <a:avLst/>
@@ -4179,7 +4166,7 @@
           <a:p>
             <a:pPr>
               <a:spcAft>
-                <a:spcPts val="300"/>
+                <a:spcPts val="400"/>
               </a:spcAft>
               <a:defRPr sz="1600">
                 <a:solidFill>
@@ -4189,13 +4176,13 @@
               </a:defRPr>
             </a:pPr>
             <a:r>
-              <a:t>Pelayanan yg disediakan restoran, termasuk:</a:t>
+              <a:t>Pelayanan yang disediakan restoran, termasuk:</a:t>
             </a:r>
           </a:p>
           <a:p>
             <a:pPr>
               <a:spcAft>
-                <a:spcPts val="300"/>
+                <a:spcPts val="400"/>
               </a:spcAft>
               <a:defRPr sz="1600">
                 <a:solidFill>
@@ -4205,13 +4192,13 @@
               </a:defRPr>
             </a:pPr>
             <a:r>
-              <a:t>   • Roti, bakery, donat</a:t>
+              <a:t>   ✓  Roti, bakery, donat</a:t>
             </a:r>
           </a:p>
           <a:p>
             <a:pPr>
               <a:spcAft>
-                <a:spcPts val="300"/>
+                <a:spcPts val="400"/>
               </a:spcAft>
               <a:defRPr sz="1600">
                 <a:solidFill>
@@ -4221,13 +4208,13 @@
               </a:defRPr>
             </a:pPr>
             <a:r>
-              <a:t>   • Katering &amp; jasa boga</a:t>
+              <a:t>   ✓  Katering &amp; jasa boga</a:t>
             </a:r>
           </a:p>
           <a:p>
             <a:pPr>
               <a:spcAft>
-                <a:spcPts val="300"/>
+                <a:spcPts val="400"/>
               </a:spcAft>
               <a:defRPr sz="1600">
                 <a:solidFill>
@@ -4237,7 +4224,7 @@
               </a:defRPr>
             </a:pPr>
             <a:r>
-              <a:t>   • Usaha sejenis — termasuk yang mobile/insidentil</a:t>
+              <a:t>   ✓  Usaha sejenis — termasuk yang bersifat mobile/insidentil</a:t>
             </a:r>
           </a:p>
         </p:txBody>
@@ -4250,7 +4237,7 @@
         </p:nvSpPr>
         <p:spPr>
           <a:xfrm>
-            <a:off x="457200" y="3017520"/>
+            <a:off x="457200" y="2834640"/>
             <a:ext cx="11247120" cy="457200"/>
           </a:xfrm>
           <a:prstGeom prst="rect">
@@ -4294,7 +4281,7 @@
         <p:spPr>
           <a:xfrm>
             <a:off x="640080" y="3035808"/>
-            <a:ext cx="10972800" cy="457200"/>
+            <a:ext cx="10058400" cy="457200"/>
           </a:xfrm>
           <a:prstGeom prst="rect">
             <a:avLst/>
@@ -4316,7 +4303,7 @@
               </a:defRPr>
             </a:pPr>
             <a:r>
-              <a:t>Ayat (2) — Lingkup Pelayanan</a:t>
+              <a:t>Ayat (2) —  Lingkup Pelayanan</a:t>
             </a:r>
           </a:p>
         </p:txBody>
@@ -4329,8 +4316,8 @@
         </p:nvSpPr>
         <p:spPr>
           <a:xfrm>
-            <a:off x="640080" y="3566160"/>
-            <a:ext cx="10972800" cy="731520"/>
+            <a:off x="640080" y="3383280"/>
+            <a:ext cx="10515600" cy="731520"/>
           </a:xfrm>
           <a:prstGeom prst="rect">
             <a:avLst/>
@@ -4345,7 +4332,7 @@
           <a:p>
             <a:pPr>
               <a:spcAft>
-                <a:spcPts val="300"/>
+                <a:spcPts val="400"/>
               </a:spcAft>
               <a:defRPr sz="1600">
                 <a:solidFill>
@@ -4355,13 +4342,13 @@
               </a:defRPr>
             </a:pPr>
             <a:r>
-              <a:t>Penjualan makanan/minuman yg dikonsumsi pembeli:</a:t>
+              <a:t>Penjualan makanan/minuman yang dikonsumsi pembeli:</a:t>
             </a:r>
           </a:p>
           <a:p>
             <a:pPr>
               <a:spcAft>
-                <a:spcPts val="300"/>
+                <a:spcPts val="400"/>
               </a:spcAft>
               <a:defRPr sz="1600">
                 <a:solidFill>
@@ -4371,13 +4358,13 @@
               </a:defRPr>
             </a:pPr>
             <a:r>
-              <a:t>   • Di tempat pelayanan (dine-in)</a:t>
+              <a:t>   ✓  Di tempat pelayanan (dine-in)</a:t>
             </a:r>
           </a:p>
           <a:p>
             <a:pPr>
               <a:spcAft>
-                <a:spcPts val="300"/>
+                <a:spcPts val="400"/>
               </a:spcAft>
               <a:defRPr sz="1600">
                 <a:solidFill>
@@ -4387,7 +4374,7 @@
               </a:defRPr>
             </a:pPr>
             <a:r>
-              <a:t>   • Di tempat lain (takeaway/delivery)</a:t>
+              <a:t>   ✓  Di tempat lain (takeaway / delivery)</a:t>
             </a:r>
           </a:p>
         </p:txBody>
@@ -4401,13 +4388,13 @@
         <p:spPr>
           <a:xfrm>
             <a:off x="457200" y="4389120"/>
-            <a:ext cx="11247120" cy="1371600"/>
+            <a:ext cx="11247120" cy="1554480"/>
           </a:xfrm>
           <a:prstGeom prst="rect">
             <a:avLst/>
           </a:prstGeom>
           <a:solidFill>
-            <a:srgbClr val="FFF3CD"/>
+            <a:srgbClr val="FBF0D0"/>
           </a:solidFill>
           <a:ln>
             <a:noFill/>
@@ -4444,13 +4431,13 @@
         <p:spPr>
           <a:xfrm>
             <a:off x="457200" y="4389120"/>
-            <a:ext cx="137160" cy="1371600"/>
+            <a:ext cx="137160" cy="1554480"/>
           </a:xfrm>
           <a:prstGeom prst="rect">
             <a:avLst/>
           </a:prstGeom>
           <a:solidFill>
-            <a:srgbClr val="FFD700"/>
+            <a:srgbClr val="F5A623"/>
           </a:solidFill>
           <a:ln>
             <a:noFill/>
@@ -4487,7 +4474,7 @@
         <p:spPr>
           <a:xfrm>
             <a:off x="822960" y="4480560"/>
-            <a:ext cx="10515600" cy="365760"/>
+            <a:ext cx="4572000" cy="365760"/>
           </a:xfrm>
           <a:prstGeom prst="rect">
             <a:avLst/>
@@ -4523,7 +4510,7 @@
         <p:spPr>
           <a:xfrm>
             <a:off x="822960" y="4937760"/>
-            <a:ext cx="10515600" cy="640080"/>
+            <a:ext cx="10515600" cy="731520"/>
           </a:xfrm>
           <a:prstGeom prst="rect">
             <a:avLst/>
@@ -4537,15 +4524,23 @@
           <a:lstStyle/>
           <a:p>
             <a:pPr algn="l">
-              <a:defRPr sz="2000" b="1">
-                <a:solidFill>
-                  <a:srgbClr val="665000"/>
+              <a:defRPr sz="1800" b="1">
+                <a:solidFill>
+                  <a:srgbClr val="5C3D00"/>
                 </a:solidFill>
                 <a:latin typeface="Calibri"/>
               </a:defRPr>
             </a:pPr>
             <a:r>
-              <a:t>Ayat (3): Omzet ≤ Rp 10.000.000/bulan → BUKAN objek pajak</a:t>
+              <a:t>Ayat (3) — Pelayanan penjualan makanan/minuman</a:t>
+            </a:r>
+            <a:br/>
+            <a:r>
+              <a:t>dengan omzet tidak melebihi Rp 10.000.000 per bulan</a:t>
+            </a:r>
+            <a:br/>
+            <a:r>
+              <a:t>TIDAK termasuk objek pajak</a:t>
             </a:r>
           </a:p>
         </p:txBody>
@@ -4624,7 +4619,7 @@
               </a:defRPr>
             </a:pPr>
             <a:r>
-              <a:t>Mengubah Pasal 3 Perda No. 08/2011</a:t>
+              <a:t>Mengubah Pasal 3 Perda Kota Bekasi No. 08/2011</a:t>
             </a:r>
           </a:p>
         </p:txBody>
@@ -4714,8 +4709,8 @@
         </p:blipFill>
         <p:spPr>
           <a:xfrm>
-            <a:off x="274320" y="91440"/>
-            <a:ext cx="548740" cy="640080"/>
+            <a:off x="457200" y="45720"/>
+            <a:ext cx="705523" cy="822960"/>
           </a:xfrm>
           <a:prstGeom prst="rect">
             <a:avLst/>
@@ -4730,8 +4725,8 @@
         </p:nvSpPr>
         <p:spPr>
           <a:xfrm>
-            <a:off x="1188720" y="137160"/>
-            <a:ext cx="10058400" cy="640080"/>
+            <a:off x="1554480" y="137160"/>
+            <a:ext cx="9144000" cy="640080"/>
           </a:xfrm>
           <a:prstGeom prst="rect">
             <a:avLst/>
@@ -4767,7 +4762,7 @@
         <p:spPr>
           <a:xfrm>
             <a:off x="457200" y="1188720"/>
-            <a:ext cx="5486400" cy="457200"/>
+            <a:ext cx="5303520" cy="457200"/>
           </a:xfrm>
           <a:prstGeom prst="rect">
             <a:avLst/>
@@ -4810,7 +4805,7 @@
         <p:spPr>
           <a:xfrm>
             <a:off x="640080" y="1207008"/>
-            <a:ext cx="5029200" cy="457200"/>
+            <a:ext cx="4937760" cy="457200"/>
           </a:xfrm>
           <a:prstGeom prst="rect">
             <a:avLst/>
@@ -4846,7 +4841,7 @@
         <p:spPr>
           <a:xfrm>
             <a:off x="640080" y="1828800"/>
-            <a:ext cx="5029200" cy="731520"/>
+            <a:ext cx="4937760" cy="640080"/>
           </a:xfrm>
           <a:prstGeom prst="rect">
             <a:avLst/>
@@ -4929,7 +4924,7 @@
         <p:spPr>
           <a:xfrm>
             <a:off x="6400800" y="1207008"/>
-            <a:ext cx="5029200" cy="457200"/>
+            <a:ext cx="5120640" cy="457200"/>
           </a:xfrm>
           <a:prstGeom prst="rect">
             <a:avLst/>
@@ -4965,7 +4960,7 @@
         <p:spPr>
           <a:xfrm>
             <a:off x="6400800" y="1828800"/>
-            <a:ext cx="5029200" cy="2286000"/>
+            <a:ext cx="5120640" cy="2286000"/>
           </a:xfrm>
           <a:prstGeom prst="rect">
             <a:avLst/>
@@ -4980,7 +4975,7 @@
           <a:p>
             <a:pPr>
               <a:spcAft>
-                <a:spcPts val="300"/>
+                <a:spcPts val="200"/>
               </a:spcAft>
               <a:defRPr sz="1500">
                 <a:solidFill>
@@ -4990,13 +4985,13 @@
               </a:defRPr>
             </a:pPr>
             <a:r>
-              <a:t>Tanggal: 3 Desember 2018</a:t>
+              <a:t>Tanggal    : 3 Desember 2018</a:t>
             </a:r>
           </a:p>
           <a:p>
             <a:pPr>
               <a:spcAft>
-                <a:spcPts val="300"/>
+                <a:spcPts val="200"/>
               </a:spcAft>
               <a:defRPr sz="1500">
                 <a:solidFill>
@@ -5006,13 +5001,13 @@
               </a:defRPr>
             </a:pPr>
             <a:r>
-              <a:t>Wali Kota: Rahmat Effendi</a:t>
+              <a:t>Wali Kota  : Rahmat Effendi</a:t>
             </a:r>
           </a:p>
           <a:p>
             <a:pPr>
               <a:spcAft>
-                <a:spcPts val="300"/>
+                <a:spcPts val="200"/>
               </a:spcAft>
               <a:defRPr sz="1500">
                 <a:solidFill>
@@ -5022,13 +5017,13 @@
               </a:defRPr>
             </a:pPr>
             <a:r>
-              <a:t>Pj. Sekda: Widodo Indrijantoro</a:t>
+              <a:t>Pj. Sekda  : Widodo Indrijantoro</a:t>
             </a:r>
           </a:p>
           <a:p>
             <a:pPr>
               <a:spcAft>
-                <a:spcPts val="300"/>
+                <a:spcPts val="200"/>
               </a:spcAft>
               <a:defRPr sz="1500">
                 <a:solidFill>
@@ -5044,7 +5039,7 @@
           <a:p>
             <a:pPr>
               <a:spcAft>
-                <a:spcPts val="300"/>
+                <a:spcPts val="200"/>
               </a:spcAft>
               <a:defRPr sz="1500">
                 <a:solidFill>
@@ -5054,13 +5049,13 @@
               </a:defRPr>
             </a:pPr>
             <a:r>
-              <a:t>Diundangkan: 3 Desember 2018</a:t>
+              <a:t>Diundangkan : 3 Desember 2018</a:t>
             </a:r>
           </a:p>
           <a:p>
             <a:pPr>
               <a:spcAft>
-                <a:spcPts val="300"/>
+                <a:spcPts val="200"/>
               </a:spcAft>
               <a:defRPr sz="1500">
                 <a:solidFill>
@@ -5070,13 +5065,13 @@
               </a:defRPr>
             </a:pPr>
             <a:r>
-              <a:t>Noreg: (11/169/2018)</a:t>
+              <a:t>Noreg       : (11/169/2018)</a:t>
             </a:r>
           </a:p>
           <a:p>
             <a:pPr>
               <a:spcAft>
-                <a:spcPts val="300"/>
+                <a:spcPts val="200"/>
               </a:spcAft>
               <a:defRPr sz="1500">
                 <a:solidFill>
@@ -5143,7 +5138,7 @@
         <p:spPr>
           <a:xfrm>
             <a:off x="640080" y="4133087"/>
-            <a:ext cx="10972800" cy="457200"/>
+            <a:ext cx="10058400" cy="457200"/>
           </a:xfrm>
           <a:prstGeom prst="rect">
             <a:avLst/>
@@ -5165,7 +5160,7 @@
               </a:defRPr>
             </a:pPr>
             <a:r>
-              <a:t>RINGKASAN ISI</a:t>
+              <a:t>RINGKASAN ISI PERDA</a:t>
             </a:r>
           </a:p>
         </p:txBody>
@@ -5179,7 +5174,7 @@
         <p:spPr>
           <a:xfrm>
             <a:off x="640080" y="4754880"/>
-            <a:ext cx="10972800" cy="1371600"/>
+            <a:ext cx="10515600" cy="1371600"/>
           </a:xfrm>
           <a:prstGeom prst="rect">
             <a:avLst/>
@@ -5194,7 +5189,7 @@
           <a:p>
             <a:pPr>
               <a:spcAft>
-                <a:spcPts val="600"/>
+                <a:spcPts val="500"/>
               </a:spcAft>
               <a:defRPr sz="1600">
                 <a:solidFill>
@@ -5204,13 +5199,13 @@
               </a:defRPr>
             </a:pPr>
             <a:r>
-              <a:t>1. Memperluas objek pajak restoran (katering, bakery, mobile, dsb)</a:t>
+              <a:t>1.  Memperluas objek pajak restoran (katering, bakery, mobile, dsb)</a:t>
             </a:r>
           </a:p>
           <a:p>
             <a:pPr>
               <a:spcAft>
-                <a:spcPts val="600"/>
+                <a:spcPts val="500"/>
               </a:spcAft>
               <a:defRPr sz="1600">
                 <a:solidFill>
@@ -5220,13 +5215,13 @@
               </a:defRPr>
             </a:pPr>
             <a:r>
-              <a:t>2. Menegaskan lingkup: dine-in &amp; takeaway/delivery</a:t>
+              <a:t>2.  Menegaskan lingkup pelayanan: dine-in &amp; takeaway/delivery</a:t>
             </a:r>
           </a:p>
           <a:p>
             <a:pPr>
               <a:spcAft>
-                <a:spcPts val="600"/>
+                <a:spcPts val="500"/>
               </a:spcAft>
               <a:defRPr sz="1600">
                 <a:solidFill>
@@ -5236,13 +5231,13 @@
               </a:defRPr>
             </a:pPr>
             <a:r>
-              <a:t>3. Pengecualian: omzet ≤ Rp 10 jt/bulan → bebas pajak</a:t>
+              <a:t>3.  Pengecualian: omzet ≤ Rp 10 juta/bulan → bukan objek pajak</a:t>
             </a:r>
           </a:p>
           <a:p>
             <a:pPr>
               <a:spcAft>
-                <a:spcPts val="600"/>
+                <a:spcPts val="500"/>
               </a:spcAft>
               <a:defRPr sz="1600">
                 <a:solidFill>
@@ -5252,7 +5247,7 @@
               </a:defRPr>
             </a:pPr>
             <a:r>
-              <a:t>4. Hanya Pasal 3 yg diubah — pasal lain tetap</a:t>
+              <a:t>4.  Hanya Pasal 3 yang diubah — pasal lainnya tidak berubah</a:t>
             </a:r>
           </a:p>
         </p:txBody>
@@ -5331,7 +5326,7 @@
               </a:defRPr>
             </a:pPr>
             <a:r>
-              <a:t>Sumber: jdih.bekasikota.go.id</a:t>
+              <a:t>Sumber: JDIH Kota Bekasi</a:t>
             </a:r>
           </a:p>
         </p:txBody>
@@ -5370,8 +5365,8 @@
         </p:nvSpPr>
         <p:spPr>
           <a:xfrm>
-            <a:off x="0" y="2286000"/>
-            <a:ext cx="12191695" cy="54864"/>
+            <a:off x="0" y="2011680"/>
+            <a:ext cx="12191695" cy="36576"/>
           </a:xfrm>
           <a:prstGeom prst="rect">
             <a:avLst/>
@@ -5413,8 +5408,8 @@
         </p:nvSpPr>
         <p:spPr>
           <a:xfrm>
-            <a:off x="0" y="4572000"/>
-            <a:ext cx="12191695" cy="54864"/>
+            <a:off x="0" y="4754880"/>
+            <a:ext cx="12191695" cy="36576"/>
           </a:xfrm>
           <a:prstGeom prst="rect">
             <a:avLst/>
@@ -5464,8 +5459,8 @@
         </p:blipFill>
         <p:spPr>
           <a:xfrm>
-            <a:off x="5120640" y="731520"/>
-            <a:ext cx="1411047" cy="1645920"/>
+            <a:off x="4846320" y="457200"/>
+            <a:ext cx="1959787" cy="2286000"/>
           </a:xfrm>
           <a:prstGeom prst="rect">
             <a:avLst/>
@@ -5480,7 +5475,7 @@
         </p:nvSpPr>
         <p:spPr>
           <a:xfrm>
-            <a:off x="914400" y="2560320"/>
+            <a:off x="914400" y="2286000"/>
             <a:ext cx="10058400" cy="914400"/>
           </a:xfrm>
           <a:prstGeom prst="rect">
@@ -5495,7 +5490,7 @@
           <a:lstStyle/>
           <a:p>
             <a:pPr algn="ctr">
-              <a:defRPr sz="4400" b="1">
+              <a:defRPr sz="4800" b="1">
                 <a:solidFill>
                   <a:srgbClr val="FFFFFF"/>
                 </a:solidFill>
@@ -5516,8 +5511,8 @@
         </p:nvSpPr>
         <p:spPr>
           <a:xfrm>
-            <a:off x="914400" y="3474720"/>
-            <a:ext cx="10058400" cy="914400"/>
+            <a:off x="1371600" y="3200400"/>
+            <a:ext cx="9144000" cy="731520"/>
           </a:xfrm>
           <a:prstGeom prst="rect">
             <a:avLst/>
@@ -5556,7 +5551,7 @@
         </p:nvSpPr>
         <p:spPr>
           <a:xfrm>
-            <a:off x="914400" y="4846320"/>
+            <a:off x="914400" y="5029200"/>
             <a:ext cx="10058400" cy="457200"/>
           </a:xfrm>
           <a:prstGeom prst="rect">
@@ -5579,7 +5574,7 @@
               </a:defRPr>
             </a:pPr>
             <a:r>
-              <a:t>Sumber: JDIH Kota Bekasi</a:t>
+              <a:t>Sumber: JDIH Kota Bekasi  •  jdih.bekasikota.go.id</a:t>
             </a:r>
           </a:p>
         </p:txBody>

</xml_diff>

<commit_message>
fix: ganti ke JPEG logo biar muncul di semua viewer
</commit_message>
<xml_diff>
--- a/Ringkasan_Perda_Bekasi_No_14_2018.pptx
+++ b/Ringkasan_Perda_Bekasi_No_14_2018.pptx
@@ -3108,7 +3108,7 @@
         </p:nvSpPr>
         <p:spPr>
           <a:xfrm>
-            <a:off x="0" y="2011680"/>
+            <a:off x="0" y="2103120"/>
             <a:ext cx="12191695" cy="36576"/>
           </a:xfrm>
           <a:prstGeom prst="rect">
@@ -3151,7 +3151,7 @@
         </p:nvSpPr>
         <p:spPr>
           <a:xfrm>
-            <a:off x="0" y="4572000"/>
+            <a:off x="0" y="4754880"/>
             <a:ext cx="12191695" cy="36576"/>
           </a:xfrm>
           <a:prstGeom prst="rect">
@@ -3188,7 +3188,7 @@
       </p:sp>
       <p:pic>
         <p:nvPicPr>
-          <p:cNvPr id="4" name="Picture 3" descr="logo_bekasi.png"/>
+          <p:cNvPr id="4" name="Picture 3" descr="logo_bekasi_jpg.jpg"/>
           <p:cNvPicPr>
             <a:picLocks noChangeAspect="1"/>
           </p:cNvPicPr>
@@ -3202,8 +3202,8 @@
         </p:blipFill>
         <p:spPr>
           <a:xfrm>
-            <a:off x="5029200" y="365760"/>
-            <a:ext cx="1724613" cy="2011680"/>
+            <a:off x="4846320" y="274320"/>
+            <a:ext cx="2038179" cy="2377440"/>
           </a:xfrm>
           <a:prstGeom prst="rect">
             <a:avLst/>
@@ -3218,8 +3218,8 @@
         </p:nvSpPr>
         <p:spPr>
           <a:xfrm>
-            <a:off x="914400" y="2286000"/>
-            <a:ext cx="10058400" cy="640080"/>
+            <a:off x="914400" y="2377440"/>
+            <a:ext cx="10058400" cy="548640"/>
           </a:xfrm>
           <a:prstGeom prst="rect">
             <a:avLst/>
@@ -3254,7 +3254,7 @@
         </p:nvSpPr>
         <p:spPr>
           <a:xfrm>
-            <a:off x="914400" y="2926080"/>
+            <a:off x="914400" y="3017520"/>
             <a:ext cx="10058400" cy="1097280"/>
           </a:xfrm>
           <a:prstGeom prst="rect">
@@ -3294,7 +3294,7 @@
         </p:nvSpPr>
         <p:spPr>
           <a:xfrm>
-            <a:off x="1371600" y="4023360"/>
+            <a:off x="1371600" y="4114800"/>
             <a:ext cx="9144000" cy="640080"/>
           </a:xfrm>
           <a:prstGeom prst="rect">
@@ -3317,11 +3317,11 @@
               </a:defRPr>
             </a:pPr>
             <a:r>
-              <a:t>Perubahan Atas Peraturan Daerah Kota Bekasi Nomor 08 Tahun 2011</a:t>
+              <a:t>Perubahan Atas Peraturan Daerah Kota Bekasi</a:t>
             </a:r>
             <a:br/>
             <a:r>
-              <a:t>Tentang Pajak Restoran</a:t>
+              <a:t>Nomor 08 Tahun 2011 Tentang Pajak Restoran</a:t>
             </a:r>
           </a:p>
         </p:txBody>
@@ -3334,7 +3334,7 @@
         </p:nvSpPr>
         <p:spPr>
           <a:xfrm>
-            <a:off x="914400" y="4846320"/>
+            <a:off x="914400" y="5029200"/>
             <a:ext cx="10058400" cy="457200"/>
           </a:xfrm>
           <a:prstGeom prst="rect">
@@ -3433,7 +3433,7 @@
       </p:sp>
       <p:pic>
         <p:nvPicPr>
-          <p:cNvPr id="3" name="Picture 2" descr="logo_bekasi.png"/>
+          <p:cNvPr id="3" name="Picture 2" descr="logo_bekasi_jpg.jpg"/>
           <p:cNvPicPr>
             <a:picLocks noChangeAspect="1"/>
           </p:cNvPicPr>
@@ -3447,8 +3447,8 @@
         </p:blipFill>
         <p:spPr>
           <a:xfrm>
-            <a:off x="457200" y="45720"/>
-            <a:ext cx="705523" cy="822960"/>
+            <a:off x="457200" y="91440"/>
+            <a:ext cx="627132" cy="731520"/>
           </a:xfrm>
           <a:prstGeom prst="rect">
             <a:avLst/>
@@ -3463,7 +3463,7 @@
         </p:nvSpPr>
         <p:spPr>
           <a:xfrm>
-            <a:off x="1554480" y="137160"/>
+            <a:off x="1463040" y="137160"/>
             <a:ext cx="9144000" cy="640080"/>
           </a:xfrm>
           <a:prstGeom prst="rect">
@@ -4005,7 +4005,7 @@
       </p:sp>
       <p:pic>
         <p:nvPicPr>
-          <p:cNvPr id="3" name="Picture 2" descr="logo_bekasi.png"/>
+          <p:cNvPr id="3" name="Picture 2" descr="logo_bekasi_jpg.jpg"/>
           <p:cNvPicPr>
             <a:picLocks noChangeAspect="1"/>
           </p:cNvPicPr>
@@ -4019,8 +4019,8 @@
         </p:blipFill>
         <p:spPr>
           <a:xfrm>
-            <a:off x="457200" y="45720"/>
-            <a:ext cx="705523" cy="822960"/>
+            <a:off x="457200" y="91440"/>
+            <a:ext cx="627132" cy="731520"/>
           </a:xfrm>
           <a:prstGeom prst="rect">
             <a:avLst/>
@@ -4035,7 +4035,7 @@
         </p:nvSpPr>
         <p:spPr>
           <a:xfrm>
-            <a:off x="1554480" y="137160"/>
+            <a:off x="1463040" y="137160"/>
             <a:ext cx="9144000" cy="640080"/>
           </a:xfrm>
           <a:prstGeom prst="rect">
@@ -4137,7 +4137,7 @@
               </a:defRPr>
             </a:pPr>
             <a:r>
-              <a:t>Ayat (1) —  Perluasan Objek Pajak</a:t>
+              <a:t>Ayat (1) — Perluasan Objek Pajak</a:t>
             </a:r>
           </a:p>
         </p:txBody>
@@ -4224,7 +4224,7 @@
               </a:defRPr>
             </a:pPr>
             <a:r>
-              <a:t>   ✓  Usaha sejenis — termasuk yang bersifat mobile/insidentil</a:t>
+              <a:t>   ✓  Usaha sejenis — termasuk yang mobile/insidentil</a:t>
             </a:r>
           </a:p>
         </p:txBody>
@@ -4303,7 +4303,7 @@
               </a:defRPr>
             </a:pPr>
             <a:r>
-              <a:t>Ayat (2) —  Lingkup Pelayanan</a:t>
+              <a:t>Ayat (2) — Lingkup Pelayanan</a:t>
             </a:r>
           </a:p>
         </p:txBody>
@@ -4524,7 +4524,7 @@
           <a:lstStyle/>
           <a:p>
             <a:pPr algn="l">
-              <a:defRPr sz="1800" b="1">
+              <a:defRPr sz="2000" b="1">
                 <a:solidFill>
                   <a:srgbClr val="5C3D00"/>
                 </a:solidFill>
@@ -4532,11 +4532,7 @@
               </a:defRPr>
             </a:pPr>
             <a:r>
-              <a:t>Ayat (3) — Pelayanan penjualan makanan/minuman</a:t>
-            </a:r>
-            <a:br/>
-            <a:r>
-              <a:t>dengan omzet tidak melebihi Rp 10.000.000 per bulan</a:t>
+              <a:t>Ayat (3) — Omzet tidak melebihi Rp 10.000.000/bulan</a:t>
             </a:r>
             <a:br/>
             <a:r>
@@ -4695,7 +4691,7 @@
       </p:sp>
       <p:pic>
         <p:nvPicPr>
-          <p:cNvPr id="3" name="Picture 2" descr="logo_bekasi.png"/>
+          <p:cNvPr id="3" name="Picture 2" descr="logo_bekasi_jpg.jpg"/>
           <p:cNvPicPr>
             <a:picLocks noChangeAspect="1"/>
           </p:cNvPicPr>
@@ -4709,8 +4705,8 @@
         </p:blipFill>
         <p:spPr>
           <a:xfrm>
-            <a:off x="457200" y="45720"/>
-            <a:ext cx="705523" cy="822960"/>
+            <a:off x="457200" y="91440"/>
+            <a:ext cx="627132" cy="731520"/>
           </a:xfrm>
           <a:prstGeom prst="rect">
             <a:avLst/>
@@ -4725,7 +4721,7 @@
         </p:nvSpPr>
         <p:spPr>
           <a:xfrm>
-            <a:off x="1554480" y="137160"/>
+            <a:off x="1463040" y="137160"/>
             <a:ext cx="9144000" cy="640080"/>
           </a:xfrm>
           <a:prstGeom prst="rect">
@@ -5215,7 +5211,7 @@
               </a:defRPr>
             </a:pPr>
             <a:r>
-              <a:t>2.  Menegaskan lingkup pelayanan: dine-in &amp; takeaway/delivery</a:t>
+              <a:t>2.  Menegaskan lingkup: dine-in &amp; takeaway/delivery</a:t>
             </a:r>
           </a:p>
           <a:p>
@@ -5247,7 +5243,7 @@
               </a:defRPr>
             </a:pPr>
             <a:r>
-              <a:t>4.  Hanya Pasal 3 yang diubah — pasal lainnya tidak berubah</a:t>
+              <a:t>4.  Hanya Pasal 3 yang diubah — pasal lain tidak berubah</a:t>
             </a:r>
           </a:p>
         </p:txBody>
@@ -5365,7 +5361,7 @@
         </p:nvSpPr>
         <p:spPr>
           <a:xfrm>
-            <a:off x="0" y="2011680"/>
+            <a:off x="0" y="2103120"/>
             <a:ext cx="12191695" cy="36576"/>
           </a:xfrm>
           <a:prstGeom prst="rect">
@@ -5408,7 +5404,7 @@
         </p:nvSpPr>
         <p:spPr>
           <a:xfrm>
-            <a:off x="0" y="4754880"/>
+            <a:off x="0" y="4846320"/>
             <a:ext cx="12191695" cy="36576"/>
           </a:xfrm>
           <a:prstGeom prst="rect">
@@ -5445,7 +5441,7 @@
       </p:sp>
       <p:pic>
         <p:nvPicPr>
-          <p:cNvPr id="4" name="Picture 3" descr="logo_bekasi.png"/>
+          <p:cNvPr id="4" name="Picture 3" descr="logo_bekasi_jpg.jpg"/>
           <p:cNvPicPr>
             <a:picLocks noChangeAspect="1"/>
           </p:cNvPicPr>
@@ -5459,8 +5455,8 @@
         </p:blipFill>
         <p:spPr>
           <a:xfrm>
-            <a:off x="4846320" y="457200"/>
-            <a:ext cx="1959787" cy="2286000"/>
+            <a:off x="4754880" y="274320"/>
+            <a:ext cx="2194961" cy="2560320"/>
           </a:xfrm>
           <a:prstGeom prst="rect">
             <a:avLst/>
@@ -5511,7 +5507,7 @@
         </p:nvSpPr>
         <p:spPr>
           <a:xfrm>
-            <a:off x="1371600" y="3200400"/>
+            <a:off x="1371600" y="3291840"/>
             <a:ext cx="9144000" cy="731520"/>
           </a:xfrm>
           <a:prstGeom prst="rect">
@@ -5551,7 +5547,7 @@
         </p:nvSpPr>
         <p:spPr>
           <a:xfrm>
-            <a:off x="914400" y="5029200"/>
+            <a:off x="914400" y="5120640"/>
             <a:ext cx="10058400" cy="457200"/>
           </a:xfrm>
           <a:prstGeom prst="rect">

</xml_diff>

<commit_message>
fix: tambah lingkaran putih di belakang logo biar keliatan
</commit_message>
<xml_diff>
--- a/Ringkasan_Perda_Bekasi_No_14_2018.pptx
+++ b/Ringkasan_Perda_Bekasi_No_14_2018.pptx
@@ -3186,9 +3186,52 @@
           </a:p>
         </p:txBody>
       </p:sp>
+      <p:sp>
+        <p:nvSpPr>
+          <p:cNvPr id="4" name="Oval 3"/>
+          <p:cNvSpPr/>
+          <p:nvPr/>
+        </p:nvSpPr>
+        <p:spPr>
+          <a:xfrm>
+            <a:off x="4489704" y="-82296"/>
+            <a:ext cx="3090672" cy="3090672"/>
+          </a:xfrm>
+          <a:prstGeom prst="ellipse">
+            <a:avLst/>
+          </a:prstGeom>
+          <a:solidFill>
+            <a:srgbClr val="FFFFFF"/>
+          </a:solidFill>
+          <a:ln>
+            <a:noFill/>
+          </a:ln>
+        </p:spPr>
+        <p:style>
+          <a:lnRef idx="1">
+            <a:schemeClr val="accent1"/>
+          </a:lnRef>
+          <a:fillRef idx="3">
+            <a:schemeClr val="accent1"/>
+          </a:fillRef>
+          <a:effectRef idx="2">
+            <a:schemeClr val="accent1"/>
+          </a:effectRef>
+          <a:fontRef idx="minor">
+            <a:schemeClr val="lt1"/>
+          </a:fontRef>
+        </p:style>
+        <p:txBody>
+          <a:bodyPr rtlCol="0" anchor="ctr"/>
+          <a:lstStyle/>
+          <a:p>
+            <a:pPr algn="ctr"/>
+          </a:p>
+        </p:txBody>
+      </p:sp>
       <p:pic>
         <p:nvPicPr>
-          <p:cNvPr id="4" name="Picture 3" descr="logo_bekasi_jpg.jpg"/>
+          <p:cNvPr id="5" name="Picture 4" descr="logo_bekasi.png"/>
           <p:cNvPicPr>
             <a:picLocks noChangeAspect="1"/>
           </p:cNvPicPr>
@@ -3212,7 +3255,7 @@
       </p:pic>
       <p:sp>
         <p:nvSpPr>
-          <p:cNvPr id="5" name="TextBox 4"/>
+          <p:cNvPr id="6" name="TextBox 5"/>
           <p:cNvSpPr txBox="1"/>
           <p:nvPr/>
         </p:nvSpPr>
@@ -3248,7 +3291,7 @@
       </p:sp>
       <p:sp>
         <p:nvSpPr>
-          <p:cNvPr id="6" name="TextBox 5"/>
+          <p:cNvPr id="7" name="TextBox 6"/>
           <p:cNvSpPr txBox="1"/>
           <p:nvPr/>
         </p:nvSpPr>
@@ -3288,7 +3331,7 @@
       </p:sp>
       <p:sp>
         <p:nvSpPr>
-          <p:cNvPr id="7" name="TextBox 6"/>
+          <p:cNvPr id="8" name="TextBox 7"/>
           <p:cNvSpPr txBox="1"/>
           <p:nvPr/>
         </p:nvSpPr>
@@ -3328,7 +3371,7 @@
       </p:sp>
       <p:sp>
         <p:nvSpPr>
-          <p:cNvPr id="8" name="TextBox 7"/>
+          <p:cNvPr id="9" name="TextBox 8"/>
           <p:cNvSpPr txBox="1"/>
           <p:nvPr/>
         </p:nvSpPr>
@@ -3431,9 +3474,52 @@
           </a:p>
         </p:txBody>
       </p:sp>
+      <p:sp>
+        <p:nvSpPr>
+          <p:cNvPr id="3" name="Oval 2"/>
+          <p:cNvSpPr/>
+          <p:nvPr/>
+        </p:nvSpPr>
+        <p:spPr>
+          <a:xfrm>
+            <a:off x="310897" y="-54863"/>
+            <a:ext cx="1024127" cy="1024127"/>
+          </a:xfrm>
+          <a:prstGeom prst="ellipse">
+            <a:avLst/>
+          </a:prstGeom>
+          <a:solidFill>
+            <a:srgbClr val="FFFFFF"/>
+          </a:solidFill>
+          <a:ln>
+            <a:noFill/>
+          </a:ln>
+        </p:spPr>
+        <p:style>
+          <a:lnRef idx="1">
+            <a:schemeClr val="accent1"/>
+          </a:lnRef>
+          <a:fillRef idx="3">
+            <a:schemeClr val="accent1"/>
+          </a:fillRef>
+          <a:effectRef idx="2">
+            <a:schemeClr val="accent1"/>
+          </a:effectRef>
+          <a:fontRef idx="minor">
+            <a:schemeClr val="lt1"/>
+          </a:fontRef>
+        </p:style>
+        <p:txBody>
+          <a:bodyPr rtlCol="0" anchor="ctr"/>
+          <a:lstStyle/>
+          <a:p>
+            <a:pPr algn="ctr"/>
+          </a:p>
+        </p:txBody>
+      </p:sp>
       <p:pic>
         <p:nvPicPr>
-          <p:cNvPr id="3" name="Picture 2" descr="logo_bekasi_jpg.jpg"/>
+          <p:cNvPr id="4" name="Picture 3" descr="logo_bekasi.png"/>
           <p:cNvPicPr>
             <a:picLocks noChangeAspect="1"/>
           </p:cNvPicPr>
@@ -3457,7 +3543,7 @@
       </p:pic>
       <p:sp>
         <p:nvSpPr>
-          <p:cNvPr id="4" name="TextBox 3"/>
+          <p:cNvPr id="5" name="TextBox 4"/>
           <p:cNvSpPr txBox="1"/>
           <p:nvPr/>
         </p:nvSpPr>
@@ -3493,7 +3579,7 @@
       </p:sp>
       <p:sp>
         <p:nvSpPr>
-          <p:cNvPr id="5" name="Rectangle 4"/>
+          <p:cNvPr id="6" name="Rectangle 5"/>
           <p:cNvSpPr/>
           <p:nvPr/>
         </p:nvSpPr>
@@ -3536,7 +3622,7 @@
       </p:sp>
       <p:sp>
         <p:nvSpPr>
-          <p:cNvPr id="6" name="TextBox 5"/>
+          <p:cNvPr id="7" name="TextBox 6"/>
           <p:cNvSpPr txBox="1"/>
           <p:nvPr/>
         </p:nvSpPr>
@@ -3572,7 +3658,7 @@
       </p:sp>
       <p:sp>
         <p:nvSpPr>
-          <p:cNvPr id="7" name="TextBox 6"/>
+          <p:cNvPr id="8" name="TextBox 7"/>
           <p:cNvSpPr txBox="1"/>
           <p:nvPr/>
         </p:nvSpPr>
@@ -3659,7 +3745,7 @@
       </p:sp>
       <p:sp>
         <p:nvSpPr>
-          <p:cNvPr id="8" name="Rectangle 7"/>
+          <p:cNvPr id="9" name="Rectangle 8"/>
           <p:cNvSpPr/>
           <p:nvPr/>
         </p:nvSpPr>
@@ -3702,7 +3788,7 @@
       </p:sp>
       <p:sp>
         <p:nvSpPr>
-          <p:cNvPr id="9" name="TextBox 8"/>
+          <p:cNvPr id="10" name="TextBox 9"/>
           <p:cNvSpPr txBox="1"/>
           <p:nvPr/>
         </p:nvSpPr>
@@ -3738,7 +3824,7 @@
       </p:sp>
       <p:sp>
         <p:nvSpPr>
-          <p:cNvPr id="10" name="TextBox 9"/>
+          <p:cNvPr id="11" name="TextBox 10"/>
           <p:cNvSpPr txBox="1"/>
           <p:nvPr/>
         </p:nvSpPr>
@@ -3857,7 +3943,7 @@
       </p:sp>
       <p:sp>
         <p:nvSpPr>
-          <p:cNvPr id="11" name="Rectangle 10"/>
+          <p:cNvPr id="12" name="Rectangle 11"/>
           <p:cNvSpPr/>
           <p:nvPr/>
         </p:nvSpPr>
@@ -3900,7 +3986,7 @@
       </p:sp>
       <p:sp>
         <p:nvSpPr>
-          <p:cNvPr id="12" name="TextBox 11"/>
+          <p:cNvPr id="13" name="TextBox 12"/>
           <p:cNvSpPr txBox="1"/>
           <p:nvPr/>
         </p:nvSpPr>
@@ -4003,9 +4089,52 @@
           </a:p>
         </p:txBody>
       </p:sp>
+      <p:sp>
+        <p:nvSpPr>
+          <p:cNvPr id="3" name="Oval 2"/>
+          <p:cNvSpPr/>
+          <p:nvPr/>
+        </p:nvSpPr>
+        <p:spPr>
+          <a:xfrm>
+            <a:off x="310897" y="-54863"/>
+            <a:ext cx="1024127" cy="1024127"/>
+          </a:xfrm>
+          <a:prstGeom prst="ellipse">
+            <a:avLst/>
+          </a:prstGeom>
+          <a:solidFill>
+            <a:srgbClr val="FFFFFF"/>
+          </a:solidFill>
+          <a:ln>
+            <a:noFill/>
+          </a:ln>
+        </p:spPr>
+        <p:style>
+          <a:lnRef idx="1">
+            <a:schemeClr val="accent1"/>
+          </a:lnRef>
+          <a:fillRef idx="3">
+            <a:schemeClr val="accent1"/>
+          </a:fillRef>
+          <a:effectRef idx="2">
+            <a:schemeClr val="accent1"/>
+          </a:effectRef>
+          <a:fontRef idx="minor">
+            <a:schemeClr val="lt1"/>
+          </a:fontRef>
+        </p:style>
+        <p:txBody>
+          <a:bodyPr rtlCol="0" anchor="ctr"/>
+          <a:lstStyle/>
+          <a:p>
+            <a:pPr algn="ctr"/>
+          </a:p>
+        </p:txBody>
+      </p:sp>
       <p:pic>
         <p:nvPicPr>
-          <p:cNvPr id="3" name="Picture 2" descr="logo_bekasi_jpg.jpg"/>
+          <p:cNvPr id="4" name="Picture 3" descr="logo_bekasi.png"/>
           <p:cNvPicPr>
             <a:picLocks noChangeAspect="1"/>
           </p:cNvPicPr>
@@ -4029,7 +4158,7 @@
       </p:pic>
       <p:sp>
         <p:nvSpPr>
-          <p:cNvPr id="4" name="TextBox 3"/>
+          <p:cNvPr id="5" name="TextBox 4"/>
           <p:cNvSpPr txBox="1"/>
           <p:nvPr/>
         </p:nvSpPr>
@@ -4065,7 +4194,7 @@
       </p:sp>
       <p:sp>
         <p:nvSpPr>
-          <p:cNvPr id="5" name="Rectangle 4"/>
+          <p:cNvPr id="6" name="Rectangle 5"/>
           <p:cNvSpPr/>
           <p:nvPr/>
         </p:nvSpPr>
@@ -4108,7 +4237,7 @@
       </p:sp>
       <p:sp>
         <p:nvSpPr>
-          <p:cNvPr id="6" name="TextBox 5"/>
+          <p:cNvPr id="7" name="TextBox 6"/>
           <p:cNvSpPr txBox="1"/>
           <p:nvPr/>
         </p:nvSpPr>
@@ -4144,7 +4273,7 @@
       </p:sp>
       <p:sp>
         <p:nvSpPr>
-          <p:cNvPr id="7" name="TextBox 6"/>
+          <p:cNvPr id="8" name="TextBox 7"/>
           <p:cNvSpPr txBox="1"/>
           <p:nvPr/>
         </p:nvSpPr>
@@ -4231,7 +4360,7 @@
       </p:sp>
       <p:sp>
         <p:nvSpPr>
-          <p:cNvPr id="8" name="Rectangle 7"/>
+          <p:cNvPr id="9" name="Rectangle 8"/>
           <p:cNvSpPr/>
           <p:nvPr/>
         </p:nvSpPr>
@@ -4274,7 +4403,7 @@
       </p:sp>
       <p:sp>
         <p:nvSpPr>
-          <p:cNvPr id="9" name="TextBox 8"/>
+          <p:cNvPr id="10" name="TextBox 9"/>
           <p:cNvSpPr txBox="1"/>
           <p:nvPr/>
         </p:nvSpPr>
@@ -4310,7 +4439,7 @@
       </p:sp>
       <p:sp>
         <p:nvSpPr>
-          <p:cNvPr id="10" name="TextBox 9"/>
+          <p:cNvPr id="11" name="TextBox 10"/>
           <p:cNvSpPr txBox="1"/>
           <p:nvPr/>
         </p:nvSpPr>
@@ -4381,7 +4510,7 @@
       </p:sp>
       <p:sp>
         <p:nvSpPr>
-          <p:cNvPr id="11" name="Rectangle 10"/>
+          <p:cNvPr id="12" name="Rectangle 11"/>
           <p:cNvSpPr/>
           <p:nvPr/>
         </p:nvSpPr>
@@ -4424,7 +4553,7 @@
       </p:sp>
       <p:sp>
         <p:nvSpPr>
-          <p:cNvPr id="12" name="Rectangle 11"/>
+          <p:cNvPr id="13" name="Rectangle 12"/>
           <p:cNvSpPr/>
           <p:nvPr/>
         </p:nvSpPr>
@@ -4467,7 +4596,7 @@
       </p:sp>
       <p:sp>
         <p:nvSpPr>
-          <p:cNvPr id="13" name="TextBox 12"/>
+          <p:cNvPr id="14" name="TextBox 13"/>
           <p:cNvSpPr txBox="1"/>
           <p:nvPr/>
         </p:nvSpPr>
@@ -4503,7 +4632,7 @@
       </p:sp>
       <p:sp>
         <p:nvSpPr>
-          <p:cNvPr id="14" name="TextBox 13"/>
+          <p:cNvPr id="15" name="TextBox 14"/>
           <p:cNvSpPr txBox="1"/>
           <p:nvPr/>
         </p:nvSpPr>
@@ -4543,7 +4672,7 @@
       </p:sp>
       <p:sp>
         <p:nvSpPr>
-          <p:cNvPr id="15" name="Rectangle 14"/>
+          <p:cNvPr id="16" name="Rectangle 15"/>
           <p:cNvSpPr/>
           <p:nvPr/>
         </p:nvSpPr>
@@ -4586,7 +4715,7 @@
       </p:sp>
       <p:sp>
         <p:nvSpPr>
-          <p:cNvPr id="16" name="TextBox 15"/>
+          <p:cNvPr id="17" name="TextBox 16"/>
           <p:cNvSpPr txBox="1"/>
           <p:nvPr/>
         </p:nvSpPr>
@@ -4689,9 +4818,52 @@
           </a:p>
         </p:txBody>
       </p:sp>
+      <p:sp>
+        <p:nvSpPr>
+          <p:cNvPr id="3" name="Oval 2"/>
+          <p:cNvSpPr/>
+          <p:nvPr/>
+        </p:nvSpPr>
+        <p:spPr>
+          <a:xfrm>
+            <a:off x="310897" y="-54863"/>
+            <a:ext cx="1024127" cy="1024127"/>
+          </a:xfrm>
+          <a:prstGeom prst="ellipse">
+            <a:avLst/>
+          </a:prstGeom>
+          <a:solidFill>
+            <a:srgbClr val="FFFFFF"/>
+          </a:solidFill>
+          <a:ln>
+            <a:noFill/>
+          </a:ln>
+        </p:spPr>
+        <p:style>
+          <a:lnRef idx="1">
+            <a:schemeClr val="accent1"/>
+          </a:lnRef>
+          <a:fillRef idx="3">
+            <a:schemeClr val="accent1"/>
+          </a:fillRef>
+          <a:effectRef idx="2">
+            <a:schemeClr val="accent1"/>
+          </a:effectRef>
+          <a:fontRef idx="minor">
+            <a:schemeClr val="lt1"/>
+          </a:fontRef>
+        </p:style>
+        <p:txBody>
+          <a:bodyPr rtlCol="0" anchor="ctr"/>
+          <a:lstStyle/>
+          <a:p>
+            <a:pPr algn="ctr"/>
+          </a:p>
+        </p:txBody>
+      </p:sp>
       <p:pic>
         <p:nvPicPr>
-          <p:cNvPr id="3" name="Picture 2" descr="logo_bekasi_jpg.jpg"/>
+          <p:cNvPr id="4" name="Picture 3" descr="logo_bekasi.png"/>
           <p:cNvPicPr>
             <a:picLocks noChangeAspect="1"/>
           </p:cNvPicPr>
@@ -4715,7 +4887,7 @@
       </p:pic>
       <p:sp>
         <p:nvSpPr>
-          <p:cNvPr id="4" name="TextBox 3"/>
+          <p:cNvPr id="5" name="TextBox 4"/>
           <p:cNvSpPr txBox="1"/>
           <p:nvPr/>
         </p:nvSpPr>
@@ -4751,7 +4923,7 @@
       </p:sp>
       <p:sp>
         <p:nvSpPr>
-          <p:cNvPr id="5" name="Rectangle 4"/>
+          <p:cNvPr id="6" name="Rectangle 5"/>
           <p:cNvSpPr/>
           <p:nvPr/>
         </p:nvSpPr>
@@ -4794,7 +4966,7 @@
       </p:sp>
       <p:sp>
         <p:nvSpPr>
-          <p:cNvPr id="6" name="TextBox 5"/>
+          <p:cNvPr id="7" name="TextBox 6"/>
           <p:cNvSpPr txBox="1"/>
           <p:nvPr/>
         </p:nvSpPr>
@@ -4830,7 +5002,7 @@
       </p:sp>
       <p:sp>
         <p:nvSpPr>
-          <p:cNvPr id="7" name="TextBox 6"/>
+          <p:cNvPr id="8" name="TextBox 7"/>
           <p:cNvSpPr txBox="1"/>
           <p:nvPr/>
         </p:nvSpPr>
@@ -4870,7 +5042,7 @@
       </p:sp>
       <p:sp>
         <p:nvSpPr>
-          <p:cNvPr id="8" name="Rectangle 7"/>
+          <p:cNvPr id="9" name="Rectangle 8"/>
           <p:cNvSpPr/>
           <p:nvPr/>
         </p:nvSpPr>
@@ -4913,7 +5085,7 @@
       </p:sp>
       <p:sp>
         <p:nvSpPr>
-          <p:cNvPr id="9" name="TextBox 8"/>
+          <p:cNvPr id="10" name="TextBox 9"/>
           <p:cNvSpPr txBox="1"/>
           <p:nvPr/>
         </p:nvSpPr>
@@ -4949,7 +5121,7 @@
       </p:sp>
       <p:sp>
         <p:nvSpPr>
-          <p:cNvPr id="10" name="TextBox 9"/>
+          <p:cNvPr id="11" name="TextBox 10"/>
           <p:cNvSpPr txBox="1"/>
           <p:nvPr/>
         </p:nvSpPr>
@@ -5084,7 +5256,7 @@
       </p:sp>
       <p:sp>
         <p:nvSpPr>
-          <p:cNvPr id="11" name="Rectangle 10"/>
+          <p:cNvPr id="12" name="Rectangle 11"/>
           <p:cNvSpPr/>
           <p:nvPr/>
         </p:nvSpPr>
@@ -5127,7 +5299,7 @@
       </p:sp>
       <p:sp>
         <p:nvSpPr>
-          <p:cNvPr id="12" name="TextBox 11"/>
+          <p:cNvPr id="13" name="TextBox 12"/>
           <p:cNvSpPr txBox="1"/>
           <p:nvPr/>
         </p:nvSpPr>
@@ -5163,7 +5335,7 @@
       </p:sp>
       <p:sp>
         <p:nvSpPr>
-          <p:cNvPr id="13" name="TextBox 12"/>
+          <p:cNvPr id="14" name="TextBox 13"/>
           <p:cNvSpPr txBox="1"/>
           <p:nvPr/>
         </p:nvSpPr>
@@ -5250,7 +5422,7 @@
       </p:sp>
       <p:sp>
         <p:nvSpPr>
-          <p:cNvPr id="14" name="Rectangle 13"/>
+          <p:cNvPr id="15" name="Rectangle 14"/>
           <p:cNvSpPr/>
           <p:nvPr/>
         </p:nvSpPr>
@@ -5293,7 +5465,7 @@
       </p:sp>
       <p:sp>
         <p:nvSpPr>
-          <p:cNvPr id="15" name="TextBox 14"/>
+          <p:cNvPr id="16" name="TextBox 15"/>
           <p:cNvSpPr txBox="1"/>
           <p:nvPr/>
         </p:nvSpPr>
@@ -5439,9 +5611,52 @@
           </a:p>
         </p:txBody>
       </p:sp>
+      <p:sp>
+        <p:nvSpPr>
+          <p:cNvPr id="4" name="Oval 3"/>
+          <p:cNvSpPr/>
+          <p:nvPr/>
+        </p:nvSpPr>
+        <p:spPr>
+          <a:xfrm>
+            <a:off x="4370832" y="-109728"/>
+            <a:ext cx="3328416" cy="3328416"/>
+          </a:xfrm>
+          <a:prstGeom prst="ellipse">
+            <a:avLst/>
+          </a:prstGeom>
+          <a:solidFill>
+            <a:srgbClr val="FFFFFF"/>
+          </a:solidFill>
+          <a:ln>
+            <a:noFill/>
+          </a:ln>
+        </p:spPr>
+        <p:style>
+          <a:lnRef idx="1">
+            <a:schemeClr val="accent1"/>
+          </a:lnRef>
+          <a:fillRef idx="3">
+            <a:schemeClr val="accent1"/>
+          </a:fillRef>
+          <a:effectRef idx="2">
+            <a:schemeClr val="accent1"/>
+          </a:effectRef>
+          <a:fontRef idx="minor">
+            <a:schemeClr val="lt1"/>
+          </a:fontRef>
+        </p:style>
+        <p:txBody>
+          <a:bodyPr rtlCol="0" anchor="ctr"/>
+          <a:lstStyle/>
+          <a:p>
+            <a:pPr algn="ctr"/>
+          </a:p>
+        </p:txBody>
+      </p:sp>
       <p:pic>
         <p:nvPicPr>
-          <p:cNvPr id="4" name="Picture 3" descr="logo_bekasi_jpg.jpg"/>
+          <p:cNvPr id="5" name="Picture 4" descr="logo_bekasi.png"/>
           <p:cNvPicPr>
             <a:picLocks noChangeAspect="1"/>
           </p:cNvPicPr>
@@ -5456,7 +5671,7 @@
         <p:spPr>
           <a:xfrm>
             <a:off x="4754880" y="274320"/>
-            <a:ext cx="2194961" cy="2560320"/>
+            <a:ext cx="2194962" cy="2560320"/>
           </a:xfrm>
           <a:prstGeom prst="rect">
             <a:avLst/>
@@ -5465,7 +5680,7 @@
       </p:pic>
       <p:sp>
         <p:nvSpPr>
-          <p:cNvPr id="5" name="TextBox 4"/>
+          <p:cNvPr id="6" name="TextBox 5"/>
           <p:cNvSpPr txBox="1"/>
           <p:nvPr/>
         </p:nvSpPr>
@@ -5501,7 +5716,7 @@
       </p:sp>
       <p:sp>
         <p:nvSpPr>
-          <p:cNvPr id="6" name="TextBox 5"/>
+          <p:cNvPr id="7" name="TextBox 6"/>
           <p:cNvSpPr txBox="1"/>
           <p:nvPr/>
         </p:nvSpPr>
@@ -5541,7 +5756,7 @@
       </p:sp>
       <p:sp>
         <p:nvSpPr>
-          <p:cNvPr id="7" name="TextBox 6"/>
+          <p:cNvPr id="8" name="TextBox 7"/>
           <p:cNvSpPr txBox="1"/>
           <p:nvPr/>
         </p:nvSpPr>

</xml_diff>